<commit_message>
build(submission): rebuild the journal packages, talks and data snapshot
- GCB, NEE and NC packages, cover letters, Reporting Summary, the Chinese
  abstract and the v3/v4 talks rebuilt with the corrected numbers
- 205 no longer drops the GBIF.org reference (data citations are kept); 212
  now resolves dotted corporate authors, so an in-text citation without an
  entry fails QC
- 231 re-renders .docx files that no step regenerated from their .md (Reporting
  Summary, Chinese abstract, Nature-family main text, tables and legends) and
  checks that every number in each .md appears in its .docx
- the Reporting Summary gives the 2024 GBIF DOI; data_and_code/ includes 191b
  and 222-231, and 220 syncs effort2024_audit/
</commit_message>
<xml_diff>
--- a/submission/GCB/figures/Figure2.pptx
+++ b/submission/GCB/figures/Figure2.pptx
@@ -13251,7 +13251,7 @@
         </p:nvSpPr>
         <p:spPr>
           <a:xfrm>
-            <a:off x="551160" y="5164920"/>
+            <a:off x="551160" y="5522040"/>
             <a:ext cx="5934240" cy="0"/>
           </a:xfrm>
           <a:prstGeom prst="line">
@@ -13294,7 +13294,7 @@
         </p:nvSpPr>
         <p:spPr>
           <a:xfrm>
-            <a:off x="551160" y="4787280"/>
+            <a:off x="551160" y="5148720"/>
             <a:ext cx="5934240" cy="0"/>
           </a:xfrm>
           <a:prstGeom prst="line">
@@ -13337,7 +13337,7 @@
         </p:nvSpPr>
         <p:spPr>
           <a:xfrm>
-            <a:off x="551160" y="4410000"/>
+            <a:off x="551160" y="4775400"/>
             <a:ext cx="5934240" cy="0"/>
           </a:xfrm>
           <a:prstGeom prst="line">
@@ -13380,7 +13380,7 @@
         </p:nvSpPr>
         <p:spPr>
           <a:xfrm>
-            <a:off x="551160" y="4032720"/>
+            <a:off x="551160" y="4402080"/>
             <a:ext cx="5934240" cy="0"/>
           </a:xfrm>
           <a:prstGeom prst="line">
@@ -13423,7 +13423,7 @@
         </p:nvSpPr>
         <p:spPr>
           <a:xfrm>
-            <a:off x="551160" y="3655080"/>
+            <a:off x="551160" y="4028760"/>
             <a:ext cx="5934240" cy="0"/>
           </a:xfrm>
           <a:prstGeom prst="line">
@@ -13466,7 +13466,50 @@
         </p:nvSpPr>
         <p:spPr>
           <a:xfrm>
-            <a:off x="551160" y="5164920"/>
+            <a:off x="551160" y="3655440"/>
+            <a:ext cx="5934240" cy="0"/>
+          </a:xfrm>
+          <a:prstGeom prst="line">
+            <a:avLst/>
+          </a:prstGeom>
+          <a:ln w="6480">
+            <a:solidFill>
+              <a:srgbClr val="EBEBEB"/>
+            </a:solidFill>
+            <a:round/>
+          </a:ln>
+        </p:spPr>
+        <p:style>
+          <a:lnRef idx="0"/>
+          <a:fillRef idx="0"/>
+          <a:effectRef idx="0"/>
+          <a:fontRef idx="minor"/>
+        </p:style>
+        <p:txBody>
+          <a:bodyPr lIns="3240" tIns="-3240" rIns="3240" bIns="-3240" anchor="t">
+            <a:noAutofit/>
+          </a:bodyPr>
+          <a:p>
+            <a:endParaRPr lang="en-US" sz="2400" b="0" u="none" strike="noStrike">
+              <a:solidFill>
+                <a:srgbClr val="000000"/>
+              </a:solidFill>
+              <a:effectLst/>
+              <a:uFillTx/>
+              <a:latin typeface="Times New Roman"/>
+            </a:endParaRPr>
+          </a:p>
+        </p:txBody>
+      </p:sp>
+      <p:sp>
+        <p:nvSpPr>
+          <p:cNvPr id="247" name=""/>
+          <p:cNvSpPr/>
+          <p:nvPr/>
+        </p:nvSpPr>
+        <p:spPr>
+          <a:xfrm>
+            <a:off x="551160" y="5148720"/>
             <a:ext cx="5913000" cy="0"/>
           </a:xfrm>
           <a:prstGeom prst="line">
@@ -13506,39 +13549,39 @@
       </p:sp>
       <p:sp>
         <p:nvSpPr>
-          <p:cNvPr id="247" name=""/>
+          <p:cNvPr id="248" name=""/>
           <p:cNvSpPr/>
           <p:nvPr/>
         </p:nvSpPr>
         <p:spPr>
           <a:xfrm>
             <a:off x="1125720" y="3678480"/>
-            <a:ext cx="4785840" cy="983520"/>
-          </a:xfrm>
-          <a:custGeom>
-            <a:avLst/>
-            <a:gdLst/>
-            <a:ahLst/>
-            <a:rect l="0" t="0" r="r" b="b"/>
-            <a:pathLst>
-              <a:path fill="none" w="13294" h="2732">
+            <a:ext cx="4785840" cy="964800"/>
+          </a:xfrm>
+          <a:custGeom>
+            <a:avLst/>
+            <a:gdLst/>
+            <a:ahLst/>
+            <a:rect l="0" t="0" r="r" b="b"/>
+            <a:pathLst>
+              <a:path fill="none" w="13294" h="2680">
                 <a:moveTo>
                   <a:pt x="0" y="0"/>
                 </a:moveTo>
                 <a:lnTo>
-                  <a:pt x="2658" y="2530"/>
-                </a:lnTo>
-                <a:lnTo>
-                  <a:pt x="5318" y="2732"/>
-                </a:lnTo>
-                <a:lnTo>
-                  <a:pt x="7976" y="2615"/>
-                </a:lnTo>
-                <a:lnTo>
-                  <a:pt x="10635" y="1780"/>
-                </a:lnTo>
-                <a:lnTo>
-                  <a:pt x="13294" y="2012"/>
+                  <a:pt x="2658" y="2482"/>
+                </a:lnTo>
+                <a:lnTo>
+                  <a:pt x="5318" y="2680"/>
+                </a:lnTo>
+                <a:lnTo>
+                  <a:pt x="7976" y="2529"/>
+                </a:lnTo>
+                <a:lnTo>
+                  <a:pt x="10635" y="1660"/>
+                </a:lnTo>
+                <a:lnTo>
+                  <a:pt x="13294" y="1859"/>
                 </a:lnTo>
               </a:path>
             </a:pathLst>
@@ -13568,39 +13611,39 @@
       </p:sp>
       <p:sp>
         <p:nvSpPr>
-          <p:cNvPr id="248" name=""/>
-          <p:cNvSpPr/>
-          <p:nvPr/>
-        </p:nvSpPr>
-        <p:spPr>
-          <a:xfrm>
-            <a:off x="1125720" y="4340520"/>
-            <a:ext cx="4785840" cy="142200"/>
-          </a:xfrm>
-          <a:custGeom>
-            <a:avLst/>
-            <a:gdLst/>
-            <a:ahLst/>
-            <a:rect l="0" t="0" r="r" b="b"/>
-            <a:pathLst>
-              <a:path fill="none" w="13294" h="395">
-                <a:moveTo>
-                  <a:pt x="0" y="225"/>
+          <p:cNvPr id="249" name=""/>
+          <p:cNvSpPr/>
+          <p:nvPr/>
+        </p:nvSpPr>
+        <p:spPr>
+          <a:xfrm>
+            <a:off x="1125720" y="4328280"/>
+            <a:ext cx="4785840" cy="140040"/>
+          </a:xfrm>
+          <a:custGeom>
+            <a:avLst/>
+            <a:gdLst/>
+            <a:ahLst/>
+            <a:rect l="0" t="0" r="r" b="b"/>
+            <a:pathLst>
+              <a:path fill="none" w="13294" h="389">
+                <a:moveTo>
+                  <a:pt x="0" y="237"/>
                 </a:moveTo>
                 <a:lnTo>
                   <a:pt x="2658" y="0"/>
                 </a:lnTo>
                 <a:lnTo>
-                  <a:pt x="5318" y="23"/>
-                </a:lnTo>
-                <a:lnTo>
-                  <a:pt x="7976" y="27"/>
-                </a:lnTo>
-                <a:lnTo>
-                  <a:pt x="10635" y="46"/>
-                </a:lnTo>
-                <a:lnTo>
-                  <a:pt x="13294" y="395"/>
+                  <a:pt x="5318" y="25"/>
+                </a:lnTo>
+                <a:lnTo>
+                  <a:pt x="7976" y="28"/>
+                </a:lnTo>
+                <a:lnTo>
+                  <a:pt x="10635" y="47"/>
+                </a:lnTo>
+                <a:lnTo>
+                  <a:pt x="13294" y="389"/>
                 </a:lnTo>
               </a:path>
             </a:pathLst>
@@ -13630,36 +13673,36 @@
       </p:sp>
       <p:sp>
         <p:nvSpPr>
-          <p:cNvPr id="249" name=""/>
-          <p:cNvSpPr/>
-          <p:nvPr/>
-        </p:nvSpPr>
-        <p:spPr>
-          <a:xfrm>
-            <a:off x="1125720" y="5173920"/>
-            <a:ext cx="4785840" cy="273600"/>
-          </a:xfrm>
-          <a:custGeom>
-            <a:avLst/>
-            <a:gdLst/>
-            <a:ahLst/>
-            <a:rect l="0" t="0" r="r" b="b"/>
-            <a:pathLst>
-              <a:path fill="none" w="13294" h="760">
-                <a:moveTo>
-                  <a:pt x="0" y="760"/>
-                </a:moveTo>
-                <a:lnTo>
-                  <a:pt x="2658" y="126"/>
-                </a:lnTo>
-                <a:lnTo>
-                  <a:pt x="5318" y="192"/>
-                </a:lnTo>
-                <a:lnTo>
-                  <a:pt x="7976" y="193"/>
-                </a:lnTo>
-                <a:lnTo>
-                  <a:pt x="10635" y="176"/>
+          <p:cNvPr id="250" name=""/>
+          <p:cNvSpPr/>
+          <p:nvPr/>
+        </p:nvSpPr>
+        <p:spPr>
+          <a:xfrm>
+            <a:off x="1125720" y="5158800"/>
+            <a:ext cx="4785840" cy="269640"/>
+          </a:xfrm>
+          <a:custGeom>
+            <a:avLst/>
+            <a:gdLst/>
+            <a:ahLst/>
+            <a:rect l="0" t="0" r="r" b="b"/>
+            <a:pathLst>
+              <a:path fill="none" w="13294" h="749">
+                <a:moveTo>
+                  <a:pt x="0" y="749"/>
+                </a:moveTo>
+                <a:lnTo>
+                  <a:pt x="2658" y="123"/>
+                </a:lnTo>
+                <a:lnTo>
+                  <a:pt x="5318" y="189"/>
+                </a:lnTo>
+                <a:lnTo>
+                  <a:pt x="7976" y="190"/>
+                </a:lnTo>
+                <a:lnTo>
+                  <a:pt x="10635" y="174"/>
                 </a:lnTo>
                 <a:lnTo>
                   <a:pt x="13294" y="0"/>
@@ -13692,39 +13735,39 @@
       </p:sp>
       <p:sp>
         <p:nvSpPr>
-          <p:cNvPr id="250" name=""/>
-          <p:cNvSpPr/>
-          <p:nvPr/>
-        </p:nvSpPr>
-        <p:spPr>
-          <a:xfrm>
-            <a:off x="1125720" y="5398920"/>
-            <a:ext cx="4785840" cy="50760"/>
-          </a:xfrm>
-          <a:custGeom>
-            <a:avLst/>
-            <a:gdLst/>
-            <a:ahLst/>
-            <a:rect l="0" t="0" r="r" b="b"/>
-            <a:pathLst>
-              <a:path fill="none" w="13294" h="141">
+          <p:cNvPr id="251" name=""/>
+          <p:cNvSpPr/>
+          <p:nvPr/>
+        </p:nvSpPr>
+        <p:spPr>
+          <a:xfrm>
+            <a:off x="1125720" y="5380200"/>
+            <a:ext cx="4785840" cy="69480"/>
+          </a:xfrm>
+          <a:custGeom>
+            <a:avLst/>
+            <a:gdLst/>
+            <a:ahLst/>
+            <a:rect l="0" t="0" r="r" b="b"/>
+            <a:pathLst>
+              <a:path fill="none" w="13294" h="193">
                 <a:moveTo>
                   <a:pt x="0" y="0"/>
                 </a:moveTo>
                 <a:lnTo>
-                  <a:pt x="2658" y="90"/>
-                </a:lnTo>
-                <a:lnTo>
-                  <a:pt x="5318" y="65"/>
-                </a:lnTo>
-                <a:lnTo>
-                  <a:pt x="7976" y="68"/>
-                </a:lnTo>
-                <a:lnTo>
-                  <a:pt x="10635" y="71"/>
-                </a:lnTo>
-                <a:lnTo>
-                  <a:pt x="13294" y="141"/>
+                  <a:pt x="2658" y="127"/>
+                </a:lnTo>
+                <a:lnTo>
+                  <a:pt x="5318" y="105"/>
+                </a:lnTo>
+                <a:lnTo>
+                  <a:pt x="7976" y="106"/>
+                </a:lnTo>
+                <a:lnTo>
+                  <a:pt x="10635" y="113"/>
+                </a:lnTo>
+                <a:lnTo>
+                  <a:pt x="13294" y="193"/>
                 </a:lnTo>
               </a:path>
             </a:pathLst>
@@ -13754,7 +13797,7 @@
       </p:sp>
       <p:sp>
         <p:nvSpPr>
-          <p:cNvPr id="251" name=""/>
+          <p:cNvPr id="252" name=""/>
           <p:cNvSpPr/>
           <p:nvPr/>
         </p:nvSpPr>
@@ -13812,7 +13855,7 @@
       </p:sp>
       <p:sp>
         <p:nvSpPr>
-          <p:cNvPr id="252" name=""/>
+          <p:cNvPr id="253" name=""/>
           <p:cNvSpPr/>
           <p:nvPr/>
         </p:nvSpPr>
@@ -13869,13 +13912,13 @@
       </p:sp>
       <p:sp>
         <p:nvSpPr>
-          <p:cNvPr id="253" name=""/>
-          <p:cNvSpPr/>
-          <p:nvPr/>
-        </p:nvSpPr>
-        <p:spPr>
-          <a:xfrm>
-            <a:off x="2051640" y="4557960"/>
+          <p:cNvPr id="254" name=""/>
+          <p:cNvSpPr/>
+          <p:nvPr/>
+        </p:nvSpPr>
+        <p:spPr>
+          <a:xfrm>
+            <a:off x="2051640" y="4540320"/>
             <a:ext cx="62640" cy="62640"/>
           </a:xfrm>
           <a:custGeom>
@@ -13927,13 +13970,13 @@
       </p:sp>
       <p:sp>
         <p:nvSpPr>
-          <p:cNvPr id="254" name=""/>
-          <p:cNvSpPr/>
-          <p:nvPr/>
-        </p:nvSpPr>
-        <p:spPr>
-          <a:xfrm>
-            <a:off x="2051640" y="4557960"/>
+          <p:cNvPr id="255" name=""/>
+          <p:cNvSpPr/>
+          <p:nvPr/>
+        </p:nvSpPr>
+        <p:spPr>
+          <a:xfrm>
+            <a:off x="2051640" y="4540320"/>
             <a:ext cx="62640" cy="62640"/>
           </a:xfrm>
           <a:custGeom>
@@ -13984,34 +14027,34 @@
       </p:sp>
       <p:sp>
         <p:nvSpPr>
-          <p:cNvPr id="255" name=""/>
-          <p:cNvSpPr/>
-          <p:nvPr/>
-        </p:nvSpPr>
-        <p:spPr>
-          <a:xfrm>
-            <a:off x="3008520" y="4630680"/>
-            <a:ext cx="63000" cy="63000"/>
-          </a:xfrm>
-          <a:custGeom>
-            <a:avLst/>
-            <a:gdLst/>
-            <a:ahLst/>
-            <a:rect l="0" t="0" r="r" b="b"/>
-            <a:pathLst>
-              <a:path w="175" h="175">
-                <a:moveTo>
-                  <a:pt x="0" y="87"/>
+          <p:cNvPr id="256" name=""/>
+          <p:cNvSpPr/>
+          <p:nvPr/>
+        </p:nvSpPr>
+        <p:spPr>
+          <a:xfrm>
+            <a:off x="3008520" y="4611600"/>
+            <a:ext cx="63000" cy="62640"/>
+          </a:xfrm>
+          <a:custGeom>
+            <a:avLst/>
+            <a:gdLst/>
+            <a:ahLst/>
+            <a:rect l="0" t="0" r="r" b="b"/>
+            <a:pathLst>
+              <a:path w="175" h="174">
+                <a:moveTo>
+                  <a:pt x="0" y="88"/>
                 </a:moveTo>
                 <a:cubicBezTo>
                   <a:pt x="0" y="-29"/>
                   <a:pt x="175" y="-29"/>
-                  <a:pt x="175" y="87"/>
-                </a:cubicBezTo>
-                <a:cubicBezTo>
-                  <a:pt x="175" y="204"/>
-                  <a:pt x="0" y="204"/>
-                  <a:pt x="0" y="87"/>
+                  <a:pt x="175" y="88"/>
+                </a:cubicBezTo>
+                <a:cubicBezTo>
+                  <a:pt x="175" y="203"/>
+                  <a:pt x="0" y="203"/>
+                  <a:pt x="0" y="88"/>
                 </a:cubicBezTo>
                 <a:close/>
               </a:path>
@@ -14042,34 +14085,34 @@
       </p:sp>
       <p:sp>
         <p:nvSpPr>
-          <p:cNvPr id="256" name=""/>
-          <p:cNvSpPr/>
-          <p:nvPr/>
-        </p:nvSpPr>
-        <p:spPr>
-          <a:xfrm>
-            <a:off x="3008520" y="4630680"/>
-            <a:ext cx="63000" cy="63000"/>
-          </a:xfrm>
-          <a:custGeom>
-            <a:avLst/>
-            <a:gdLst/>
-            <a:ahLst/>
-            <a:rect l="0" t="0" r="r" b="b"/>
-            <a:pathLst>
-              <a:path fill="none" w="175" h="175">
-                <a:moveTo>
-                  <a:pt x="175" y="87"/>
-                </a:moveTo>
-                <a:cubicBezTo>
-                  <a:pt x="175" y="204"/>
-                  <a:pt x="0" y="204"/>
-                  <a:pt x="0" y="87"/>
+          <p:cNvPr id="257" name=""/>
+          <p:cNvSpPr/>
+          <p:nvPr/>
+        </p:nvSpPr>
+        <p:spPr>
+          <a:xfrm>
+            <a:off x="3008520" y="4611600"/>
+            <a:ext cx="63000" cy="62640"/>
+          </a:xfrm>
+          <a:custGeom>
+            <a:avLst/>
+            <a:gdLst/>
+            <a:ahLst/>
+            <a:rect l="0" t="0" r="r" b="b"/>
+            <a:pathLst>
+              <a:path fill="none" w="175" h="174">
+                <a:moveTo>
+                  <a:pt x="175" y="88"/>
+                </a:moveTo>
+                <a:cubicBezTo>
+                  <a:pt x="175" y="203"/>
+                  <a:pt x="0" y="203"/>
+                  <a:pt x="0" y="88"/>
                 </a:cubicBezTo>
                 <a:cubicBezTo>
                   <a:pt x="0" y="-29"/>
                   <a:pt x="175" y="-29"/>
-                  <a:pt x="175" y="87"/>
+                  <a:pt x="175" y="88"/>
                 </a:cubicBezTo>
               </a:path>
             </a:pathLst>
@@ -14099,13 +14142,13 @@
       </p:sp>
       <p:sp>
         <p:nvSpPr>
-          <p:cNvPr id="257" name=""/>
-          <p:cNvSpPr/>
-          <p:nvPr/>
-        </p:nvSpPr>
-        <p:spPr>
-          <a:xfrm>
-            <a:off x="3965760" y="4588200"/>
+          <p:cNvPr id="258" name=""/>
+          <p:cNvSpPr/>
+          <p:nvPr/>
+        </p:nvSpPr>
+        <p:spPr>
+          <a:xfrm>
+            <a:off x="3965760" y="4557240"/>
             <a:ext cx="62640" cy="62640"/>
           </a:xfrm>
           <a:custGeom>
@@ -14116,17 +14159,17 @@
             <a:pathLst>
               <a:path w="174" h="174">
                 <a:moveTo>
-                  <a:pt x="0" y="86"/>
+                  <a:pt x="0" y="88"/>
                 </a:moveTo>
                 <a:cubicBezTo>
                   <a:pt x="0" y="-29"/>
                   <a:pt x="174" y="-29"/>
-                  <a:pt x="174" y="86"/>
+                  <a:pt x="174" y="88"/>
                 </a:cubicBezTo>
                 <a:cubicBezTo>
                   <a:pt x="174" y="203"/>
                   <a:pt x="0" y="203"/>
-                  <a:pt x="0" y="86"/>
+                  <a:pt x="0" y="88"/>
                 </a:cubicBezTo>
                 <a:close/>
               </a:path>
@@ -14157,13 +14200,13 @@
       </p:sp>
       <p:sp>
         <p:nvSpPr>
-          <p:cNvPr id="258" name=""/>
-          <p:cNvSpPr/>
-          <p:nvPr/>
-        </p:nvSpPr>
-        <p:spPr>
-          <a:xfrm>
-            <a:off x="3965760" y="4588200"/>
+          <p:cNvPr id="259" name=""/>
+          <p:cNvSpPr/>
+          <p:nvPr/>
+        </p:nvSpPr>
+        <p:spPr>
+          <a:xfrm>
+            <a:off x="3965760" y="4557240"/>
             <a:ext cx="62640" cy="62640"/>
           </a:xfrm>
           <a:custGeom>
@@ -14174,17 +14217,17 @@
             <a:pathLst>
               <a:path fill="none" w="174" h="174">
                 <a:moveTo>
-                  <a:pt x="174" y="86"/>
+                  <a:pt x="174" y="88"/>
                 </a:moveTo>
                 <a:cubicBezTo>
                   <a:pt x="174" y="203"/>
                   <a:pt x="0" y="203"/>
-                  <a:pt x="0" y="86"/>
+                  <a:pt x="0" y="88"/>
                 </a:cubicBezTo>
                 <a:cubicBezTo>
                   <a:pt x="0" y="-29"/>
                   <a:pt x="174" y="-29"/>
-                  <a:pt x="174" y="86"/>
+                  <a:pt x="174" y="88"/>
                 </a:cubicBezTo>
               </a:path>
             </a:pathLst>
@@ -14214,13 +14257,13 @@
       </p:sp>
       <p:sp>
         <p:nvSpPr>
-          <p:cNvPr id="259" name=""/>
-          <p:cNvSpPr/>
-          <p:nvPr/>
-        </p:nvSpPr>
-        <p:spPr>
-          <a:xfrm>
-            <a:off x="4923000" y="4288320"/>
+          <p:cNvPr id="260" name=""/>
+          <p:cNvSpPr/>
+          <p:nvPr/>
+        </p:nvSpPr>
+        <p:spPr>
+          <a:xfrm>
+            <a:off x="4923000" y="4244760"/>
             <a:ext cx="62640" cy="62640"/>
           </a:xfrm>
           <a:custGeom>
@@ -14231,17 +14274,17 @@
             <a:pathLst>
               <a:path w="174" h="174">
                 <a:moveTo>
-                  <a:pt x="0" y="86"/>
+                  <a:pt x="0" y="87"/>
                 </a:moveTo>
                 <a:cubicBezTo>
                   <a:pt x="0" y="-29"/>
                   <a:pt x="174" y="-29"/>
-                  <a:pt x="174" y="86"/>
+                  <a:pt x="174" y="87"/>
                 </a:cubicBezTo>
                 <a:cubicBezTo>
                   <a:pt x="174" y="203"/>
                   <a:pt x="0" y="203"/>
-                  <a:pt x="0" y="86"/>
+                  <a:pt x="0" y="87"/>
                 </a:cubicBezTo>
                 <a:close/>
               </a:path>
@@ -14272,13 +14315,13 @@
       </p:sp>
       <p:sp>
         <p:nvSpPr>
-          <p:cNvPr id="260" name=""/>
-          <p:cNvSpPr/>
-          <p:nvPr/>
-        </p:nvSpPr>
-        <p:spPr>
-          <a:xfrm>
-            <a:off x="4923000" y="4288320"/>
+          <p:cNvPr id="261" name=""/>
+          <p:cNvSpPr/>
+          <p:nvPr/>
+        </p:nvSpPr>
+        <p:spPr>
+          <a:xfrm>
+            <a:off x="4923000" y="4244760"/>
             <a:ext cx="62640" cy="62640"/>
           </a:xfrm>
           <a:custGeom>
@@ -14289,17 +14332,17 @@
             <a:pathLst>
               <a:path fill="none" w="174" h="174">
                 <a:moveTo>
-                  <a:pt x="174" y="86"/>
+                  <a:pt x="174" y="87"/>
                 </a:moveTo>
                 <a:cubicBezTo>
                   <a:pt x="174" y="203"/>
                   <a:pt x="0" y="203"/>
-                  <a:pt x="0" y="86"/>
+                  <a:pt x="0" y="87"/>
                 </a:cubicBezTo>
                 <a:cubicBezTo>
                   <a:pt x="0" y="-29"/>
                   <a:pt x="174" y="-29"/>
-                  <a:pt x="174" y="86"/>
+                  <a:pt x="174" y="87"/>
                 </a:cubicBezTo>
               </a:path>
             </a:pathLst>
@@ -14329,13 +14372,13 @@
       </p:sp>
       <p:sp>
         <p:nvSpPr>
-          <p:cNvPr id="261" name=""/>
-          <p:cNvSpPr/>
-          <p:nvPr/>
-        </p:nvSpPr>
-        <p:spPr>
-          <a:xfrm>
-            <a:off x="5879880" y="4371480"/>
+          <p:cNvPr id="262" name=""/>
+          <p:cNvSpPr/>
+          <p:nvPr/>
+        </p:nvSpPr>
+        <p:spPr>
+          <a:xfrm>
+            <a:off x="5879880" y="4316040"/>
             <a:ext cx="62640" cy="62640"/>
           </a:xfrm>
           <a:custGeom>
@@ -14387,13 +14430,13 @@
       </p:sp>
       <p:sp>
         <p:nvSpPr>
-          <p:cNvPr id="262" name=""/>
-          <p:cNvSpPr/>
-          <p:nvPr/>
-        </p:nvSpPr>
-        <p:spPr>
-          <a:xfrm>
-            <a:off x="5879880" y="4371480"/>
+          <p:cNvPr id="263" name=""/>
+          <p:cNvSpPr/>
+          <p:nvPr/>
+        </p:nvSpPr>
+        <p:spPr>
+          <a:xfrm>
+            <a:off x="5879880" y="4316040"/>
             <a:ext cx="62640" cy="62640"/>
           </a:xfrm>
           <a:custGeom>
@@ -14444,13 +14487,13 @@
       </p:sp>
       <p:sp>
         <p:nvSpPr>
-          <p:cNvPr id="263" name=""/>
-          <p:cNvSpPr/>
-          <p:nvPr/>
-        </p:nvSpPr>
-        <p:spPr>
-          <a:xfrm>
-            <a:off x="1094400" y="4390200"/>
+          <p:cNvPr id="264" name=""/>
+          <p:cNvSpPr/>
+          <p:nvPr/>
+        </p:nvSpPr>
+        <p:spPr>
+          <a:xfrm>
+            <a:off x="1094400" y="4381920"/>
             <a:ext cx="62640" cy="63000"/>
           </a:xfrm>
           <a:custGeom>
@@ -14461,17 +14504,17 @@
             <a:pathLst>
               <a:path w="174" h="175">
                 <a:moveTo>
-                  <a:pt x="0" y="88"/>
+                  <a:pt x="0" y="87"/>
                 </a:moveTo>
                 <a:cubicBezTo>
                   <a:pt x="0" y="-29"/>
                   <a:pt x="174" y="-29"/>
-                  <a:pt x="174" y="88"/>
+                  <a:pt x="174" y="87"/>
                 </a:cubicBezTo>
                 <a:cubicBezTo>
                   <a:pt x="174" y="204"/>
                   <a:pt x="0" y="204"/>
-                  <a:pt x="0" y="88"/>
+                  <a:pt x="0" y="87"/>
                 </a:cubicBezTo>
                 <a:close/>
               </a:path>
@@ -14502,13 +14545,13 @@
       </p:sp>
       <p:sp>
         <p:nvSpPr>
-          <p:cNvPr id="264" name=""/>
-          <p:cNvSpPr/>
-          <p:nvPr/>
-        </p:nvSpPr>
-        <p:spPr>
-          <a:xfrm>
-            <a:off x="1094400" y="4390200"/>
+          <p:cNvPr id="265" name=""/>
+          <p:cNvSpPr/>
+          <p:nvPr/>
+        </p:nvSpPr>
+        <p:spPr>
+          <a:xfrm>
+            <a:off x="1094400" y="4381920"/>
             <a:ext cx="62640" cy="63000"/>
           </a:xfrm>
           <a:custGeom>
@@ -14519,17 +14562,17 @@
             <a:pathLst>
               <a:path fill="none" w="174" h="175">
                 <a:moveTo>
-                  <a:pt x="174" y="88"/>
+                  <a:pt x="174" y="87"/>
                 </a:moveTo>
                 <a:cubicBezTo>
                   <a:pt x="174" y="204"/>
                   <a:pt x="0" y="204"/>
-                  <a:pt x="0" y="88"/>
+                  <a:pt x="0" y="87"/>
                 </a:cubicBezTo>
                 <a:cubicBezTo>
                   <a:pt x="0" y="-29"/>
                   <a:pt x="174" y="-29"/>
-                  <a:pt x="174" y="88"/>
+                  <a:pt x="174" y="87"/>
                 </a:cubicBezTo>
               </a:path>
             </a:pathLst>
@@ -14559,13 +14602,13 @@
       </p:sp>
       <p:sp>
         <p:nvSpPr>
-          <p:cNvPr id="265" name=""/>
-          <p:cNvSpPr/>
-          <p:nvPr/>
-        </p:nvSpPr>
-        <p:spPr>
-          <a:xfrm>
-            <a:off x="2051640" y="4309200"/>
+          <p:cNvPr id="266" name=""/>
+          <p:cNvSpPr/>
+          <p:nvPr/>
+        </p:nvSpPr>
+        <p:spPr>
+          <a:xfrm>
+            <a:off x="2051640" y="4296960"/>
             <a:ext cx="62640" cy="62640"/>
           </a:xfrm>
           <a:custGeom>
@@ -14576,17 +14619,17 @@
             <a:pathLst>
               <a:path w="174" h="174">
                 <a:moveTo>
-                  <a:pt x="0" y="88"/>
+                  <a:pt x="0" y="87"/>
                 </a:moveTo>
                 <a:cubicBezTo>
                   <a:pt x="0" y="-29"/>
                   <a:pt x="174" y="-29"/>
-                  <a:pt x="174" y="88"/>
+                  <a:pt x="174" y="87"/>
                 </a:cubicBezTo>
                 <a:cubicBezTo>
                   <a:pt x="174" y="203"/>
                   <a:pt x="0" y="203"/>
-                  <a:pt x="0" y="88"/>
+                  <a:pt x="0" y="87"/>
                 </a:cubicBezTo>
                 <a:close/>
               </a:path>
@@ -14617,13 +14660,13 @@
       </p:sp>
       <p:sp>
         <p:nvSpPr>
-          <p:cNvPr id="266" name=""/>
-          <p:cNvSpPr/>
-          <p:nvPr/>
-        </p:nvSpPr>
-        <p:spPr>
-          <a:xfrm>
-            <a:off x="2051640" y="4309200"/>
+          <p:cNvPr id="267" name=""/>
+          <p:cNvSpPr/>
+          <p:nvPr/>
+        </p:nvSpPr>
+        <p:spPr>
+          <a:xfrm>
+            <a:off x="2051640" y="4296960"/>
             <a:ext cx="62640" cy="62640"/>
           </a:xfrm>
           <a:custGeom>
@@ -14634,17 +14677,17 @@
             <a:pathLst>
               <a:path fill="none" w="174" h="174">
                 <a:moveTo>
-                  <a:pt x="174" y="88"/>
+                  <a:pt x="174" y="87"/>
                 </a:moveTo>
                 <a:cubicBezTo>
                   <a:pt x="174" y="203"/>
                   <a:pt x="0" y="203"/>
-                  <a:pt x="0" y="88"/>
+                  <a:pt x="0" y="87"/>
                 </a:cubicBezTo>
                 <a:cubicBezTo>
                   <a:pt x="0" y="-29"/>
                   <a:pt x="174" y="-29"/>
-                  <a:pt x="174" y="88"/>
+                  <a:pt x="174" y="87"/>
                 </a:cubicBezTo>
               </a:path>
             </a:pathLst>
@@ -14674,13 +14717,13 @@
       </p:sp>
       <p:sp>
         <p:nvSpPr>
-          <p:cNvPr id="267" name=""/>
-          <p:cNvSpPr/>
-          <p:nvPr/>
-        </p:nvSpPr>
-        <p:spPr>
-          <a:xfrm>
-            <a:off x="3008520" y="4317480"/>
+          <p:cNvPr id="268" name=""/>
+          <p:cNvSpPr/>
+          <p:nvPr/>
+        </p:nvSpPr>
+        <p:spPr>
+          <a:xfrm>
+            <a:off x="3008520" y="4305960"/>
             <a:ext cx="63000" cy="62640"/>
           </a:xfrm>
           <a:custGeom>
@@ -14691,17 +14734,17 @@
             <a:pathLst>
               <a:path w="175" h="174">
                 <a:moveTo>
-                  <a:pt x="0" y="87"/>
+                  <a:pt x="0" y="88"/>
                 </a:moveTo>
                 <a:cubicBezTo>
                   <a:pt x="0" y="-29"/>
                   <a:pt x="175" y="-29"/>
-                  <a:pt x="175" y="87"/>
+                  <a:pt x="175" y="88"/>
                 </a:cubicBezTo>
                 <a:cubicBezTo>
                   <a:pt x="175" y="203"/>
                   <a:pt x="0" y="203"/>
-                  <a:pt x="0" y="87"/>
+                  <a:pt x="0" y="88"/>
                 </a:cubicBezTo>
                 <a:close/>
               </a:path>
@@ -14732,13 +14775,13 @@
       </p:sp>
       <p:sp>
         <p:nvSpPr>
-          <p:cNvPr id="268" name=""/>
-          <p:cNvSpPr/>
-          <p:nvPr/>
-        </p:nvSpPr>
-        <p:spPr>
-          <a:xfrm>
-            <a:off x="3008520" y="4317480"/>
+          <p:cNvPr id="269" name=""/>
+          <p:cNvSpPr/>
+          <p:nvPr/>
+        </p:nvSpPr>
+        <p:spPr>
+          <a:xfrm>
+            <a:off x="3008520" y="4305960"/>
             <a:ext cx="63000" cy="62640"/>
           </a:xfrm>
           <a:custGeom>
@@ -14749,17 +14792,17 @@
             <a:pathLst>
               <a:path fill="none" w="175" h="174">
                 <a:moveTo>
-                  <a:pt x="175" y="87"/>
+                  <a:pt x="175" y="88"/>
                 </a:moveTo>
                 <a:cubicBezTo>
                   <a:pt x="175" y="203"/>
                   <a:pt x="0" y="203"/>
-                  <a:pt x="0" y="87"/>
+                  <a:pt x="0" y="88"/>
                 </a:cubicBezTo>
                 <a:cubicBezTo>
                   <a:pt x="0" y="-29"/>
                   <a:pt x="175" y="-29"/>
-                  <a:pt x="175" y="87"/>
+                  <a:pt x="175" y="88"/>
                 </a:cubicBezTo>
               </a:path>
             </a:pathLst>
@@ -14789,22 +14832,22 @@
       </p:sp>
       <p:sp>
         <p:nvSpPr>
-          <p:cNvPr id="269" name=""/>
-          <p:cNvSpPr/>
-          <p:nvPr/>
-        </p:nvSpPr>
-        <p:spPr>
-          <a:xfrm>
-            <a:off x="3965760" y="4318920"/>
-            <a:ext cx="62640" cy="63000"/>
-          </a:xfrm>
-          <a:custGeom>
-            <a:avLst/>
-            <a:gdLst/>
-            <a:ahLst/>
-            <a:rect l="0" t="0" r="r" b="b"/>
-            <a:pathLst>
-              <a:path w="174" h="175">
+          <p:cNvPr id="270" name=""/>
+          <p:cNvSpPr/>
+          <p:nvPr/>
+        </p:nvSpPr>
+        <p:spPr>
+          <a:xfrm>
+            <a:off x="3965760" y="4307040"/>
+            <a:ext cx="62640" cy="62640"/>
+          </a:xfrm>
+          <a:custGeom>
+            <a:avLst/>
+            <a:gdLst/>
+            <a:ahLst/>
+            <a:rect l="0" t="0" r="r" b="b"/>
+            <a:pathLst>
+              <a:path w="174" h="174">
                 <a:moveTo>
                   <a:pt x="0" y="88"/>
                 </a:moveTo>
@@ -14814,8 +14857,8 @@
                   <a:pt x="174" y="88"/>
                 </a:cubicBezTo>
                 <a:cubicBezTo>
-                  <a:pt x="174" y="204"/>
-                  <a:pt x="0" y="204"/>
+                  <a:pt x="174" y="203"/>
+                  <a:pt x="0" y="203"/>
                   <a:pt x="0" y="88"/>
                 </a:cubicBezTo>
                 <a:close/>
@@ -14847,28 +14890,28 @@
       </p:sp>
       <p:sp>
         <p:nvSpPr>
-          <p:cNvPr id="270" name=""/>
-          <p:cNvSpPr/>
-          <p:nvPr/>
-        </p:nvSpPr>
-        <p:spPr>
-          <a:xfrm>
-            <a:off x="3965760" y="4318920"/>
-            <a:ext cx="62640" cy="63000"/>
-          </a:xfrm>
-          <a:custGeom>
-            <a:avLst/>
-            <a:gdLst/>
-            <a:ahLst/>
-            <a:rect l="0" t="0" r="r" b="b"/>
-            <a:pathLst>
-              <a:path fill="none" w="174" h="175">
+          <p:cNvPr id="271" name=""/>
+          <p:cNvSpPr/>
+          <p:nvPr/>
+        </p:nvSpPr>
+        <p:spPr>
+          <a:xfrm>
+            <a:off x="3965760" y="4307040"/>
+            <a:ext cx="62640" cy="62640"/>
+          </a:xfrm>
+          <a:custGeom>
+            <a:avLst/>
+            <a:gdLst/>
+            <a:ahLst/>
+            <a:rect l="0" t="0" r="r" b="b"/>
+            <a:pathLst>
+              <a:path fill="none" w="174" h="174">
                 <a:moveTo>
                   <a:pt x="174" y="88"/>
                 </a:moveTo>
                 <a:cubicBezTo>
-                  <a:pt x="174" y="204"/>
-                  <a:pt x="0" y="204"/>
+                  <a:pt x="174" y="203"/>
+                  <a:pt x="0" y="203"/>
                   <a:pt x="0" y="88"/>
                 </a:cubicBezTo>
                 <a:cubicBezTo>
@@ -14904,22 +14947,22 @@
       </p:sp>
       <p:sp>
         <p:nvSpPr>
-          <p:cNvPr id="271" name=""/>
-          <p:cNvSpPr/>
-          <p:nvPr/>
-        </p:nvSpPr>
-        <p:spPr>
-          <a:xfrm>
-            <a:off x="4923000" y="4325760"/>
-            <a:ext cx="62640" cy="63000"/>
-          </a:xfrm>
-          <a:custGeom>
-            <a:avLst/>
-            <a:gdLst/>
-            <a:ahLst/>
-            <a:rect l="0" t="0" r="r" b="b"/>
-            <a:pathLst>
-              <a:path w="174" h="175">
+          <p:cNvPr id="272" name=""/>
+          <p:cNvSpPr/>
+          <p:nvPr/>
+        </p:nvSpPr>
+        <p:spPr>
+          <a:xfrm>
+            <a:off x="4923000" y="4313880"/>
+            <a:ext cx="62640" cy="62640"/>
+          </a:xfrm>
+          <a:custGeom>
+            <a:avLst/>
+            <a:gdLst/>
+            <a:ahLst/>
+            <a:rect l="0" t="0" r="r" b="b"/>
+            <a:pathLst>
+              <a:path w="174" h="174">
                 <a:moveTo>
                   <a:pt x="0" y="88"/>
                 </a:moveTo>
@@ -14929,8 +14972,8 @@
                   <a:pt x="174" y="88"/>
                 </a:cubicBezTo>
                 <a:cubicBezTo>
-                  <a:pt x="174" y="204"/>
-                  <a:pt x="0" y="204"/>
+                  <a:pt x="174" y="203"/>
+                  <a:pt x="0" y="203"/>
                   <a:pt x="0" y="88"/>
                 </a:cubicBezTo>
                 <a:close/>
@@ -14962,28 +15005,28 @@
       </p:sp>
       <p:sp>
         <p:nvSpPr>
-          <p:cNvPr id="272" name=""/>
-          <p:cNvSpPr/>
-          <p:nvPr/>
-        </p:nvSpPr>
-        <p:spPr>
-          <a:xfrm>
-            <a:off x="4923000" y="4325760"/>
-            <a:ext cx="62640" cy="63000"/>
-          </a:xfrm>
-          <a:custGeom>
-            <a:avLst/>
-            <a:gdLst/>
-            <a:ahLst/>
-            <a:rect l="0" t="0" r="r" b="b"/>
-            <a:pathLst>
-              <a:path fill="none" w="174" h="175">
+          <p:cNvPr id="273" name=""/>
+          <p:cNvSpPr/>
+          <p:nvPr/>
+        </p:nvSpPr>
+        <p:spPr>
+          <a:xfrm>
+            <a:off x="4923000" y="4313880"/>
+            <a:ext cx="62640" cy="62640"/>
+          </a:xfrm>
+          <a:custGeom>
+            <a:avLst/>
+            <a:gdLst/>
+            <a:ahLst/>
+            <a:rect l="0" t="0" r="r" b="b"/>
+            <a:pathLst>
+              <a:path fill="none" w="174" h="174">
                 <a:moveTo>
                   <a:pt x="174" y="88"/>
                 </a:moveTo>
                 <a:cubicBezTo>
-                  <a:pt x="174" y="204"/>
-                  <a:pt x="0" y="204"/>
+                  <a:pt x="174" y="203"/>
+                  <a:pt x="0" y="203"/>
                   <a:pt x="0" y="88"/>
                 </a:cubicBezTo>
                 <a:cubicBezTo>
@@ -15019,22 +15062,22 @@
       </p:sp>
       <p:sp>
         <p:nvSpPr>
-          <p:cNvPr id="273" name=""/>
-          <p:cNvSpPr/>
-          <p:nvPr/>
-        </p:nvSpPr>
-        <p:spPr>
-          <a:xfrm>
-            <a:off x="5879880" y="4451040"/>
-            <a:ext cx="62640" cy="63360"/>
-          </a:xfrm>
-          <a:custGeom>
-            <a:avLst/>
-            <a:gdLst/>
-            <a:ahLst/>
-            <a:rect l="0" t="0" r="r" b="b"/>
-            <a:pathLst>
-              <a:path w="174" h="176">
+          <p:cNvPr id="274" name=""/>
+          <p:cNvSpPr/>
+          <p:nvPr/>
+        </p:nvSpPr>
+        <p:spPr>
+          <a:xfrm>
+            <a:off x="5879880" y="4436640"/>
+            <a:ext cx="62640" cy="62640"/>
+          </a:xfrm>
+          <a:custGeom>
+            <a:avLst/>
+            <a:gdLst/>
+            <a:ahLst/>
+            <a:rect l="0" t="0" r="r" b="b"/>
+            <a:pathLst>
+              <a:path w="174" h="174">
                 <a:moveTo>
                   <a:pt x="0" y="88"/>
                 </a:moveTo>
@@ -15044,8 +15087,8 @@
                   <a:pt x="174" y="88"/>
                 </a:cubicBezTo>
                 <a:cubicBezTo>
-                  <a:pt x="174" y="205"/>
-                  <a:pt x="0" y="205"/>
+                  <a:pt x="174" y="203"/>
+                  <a:pt x="0" y="203"/>
                   <a:pt x="0" y="88"/>
                 </a:cubicBezTo>
                 <a:close/>
@@ -15077,28 +15120,28 @@
       </p:sp>
       <p:sp>
         <p:nvSpPr>
-          <p:cNvPr id="274" name=""/>
-          <p:cNvSpPr/>
-          <p:nvPr/>
-        </p:nvSpPr>
-        <p:spPr>
-          <a:xfrm>
-            <a:off x="5879880" y="4451040"/>
-            <a:ext cx="62640" cy="63360"/>
-          </a:xfrm>
-          <a:custGeom>
-            <a:avLst/>
-            <a:gdLst/>
-            <a:ahLst/>
-            <a:rect l="0" t="0" r="r" b="b"/>
-            <a:pathLst>
-              <a:path fill="none" w="174" h="176">
+          <p:cNvPr id="275" name=""/>
+          <p:cNvSpPr/>
+          <p:nvPr/>
+        </p:nvSpPr>
+        <p:spPr>
+          <a:xfrm>
+            <a:off x="5879880" y="4436640"/>
+            <a:ext cx="62640" cy="62640"/>
+          </a:xfrm>
+          <a:custGeom>
+            <a:avLst/>
+            <a:gdLst/>
+            <a:ahLst/>
+            <a:rect l="0" t="0" r="r" b="b"/>
+            <a:pathLst>
+              <a:path fill="none" w="174" h="174">
                 <a:moveTo>
                   <a:pt x="174" y="88"/>
                 </a:moveTo>
                 <a:cubicBezTo>
-                  <a:pt x="174" y="205"/>
-                  <a:pt x="0" y="205"/>
+                  <a:pt x="174" y="203"/>
+                  <a:pt x="0" y="203"/>
                   <a:pt x="0" y="88"/>
                 </a:cubicBezTo>
                 <a:cubicBezTo>
@@ -15134,34 +15177,34 @@
       </p:sp>
       <p:sp>
         <p:nvSpPr>
-          <p:cNvPr id="275" name=""/>
-          <p:cNvSpPr/>
-          <p:nvPr/>
-        </p:nvSpPr>
-        <p:spPr>
-          <a:xfrm>
-            <a:off x="1094400" y="5416200"/>
-            <a:ext cx="62640" cy="62640"/>
-          </a:xfrm>
-          <a:custGeom>
-            <a:avLst/>
-            <a:gdLst/>
-            <a:ahLst/>
-            <a:rect l="0" t="0" r="r" b="b"/>
-            <a:pathLst>
-              <a:path w="174" h="174">
-                <a:moveTo>
-                  <a:pt x="0" y="86"/>
+          <p:cNvPr id="276" name=""/>
+          <p:cNvSpPr/>
+          <p:nvPr/>
+        </p:nvSpPr>
+        <p:spPr>
+          <a:xfrm>
+            <a:off x="1094400" y="5396760"/>
+            <a:ext cx="62640" cy="63000"/>
+          </a:xfrm>
+          <a:custGeom>
+            <a:avLst/>
+            <a:gdLst/>
+            <a:ahLst/>
+            <a:rect l="0" t="0" r="r" b="b"/>
+            <a:pathLst>
+              <a:path w="174" h="175">
+                <a:moveTo>
+                  <a:pt x="0" y="88"/>
                 </a:moveTo>
                 <a:cubicBezTo>
                   <a:pt x="0" y="-29"/>
                   <a:pt x="174" y="-29"/>
-                  <a:pt x="174" y="86"/>
-                </a:cubicBezTo>
-                <a:cubicBezTo>
-                  <a:pt x="174" y="203"/>
-                  <a:pt x="0" y="203"/>
-                  <a:pt x="0" y="86"/>
+                  <a:pt x="174" y="88"/>
+                </a:cubicBezTo>
+                <a:cubicBezTo>
+                  <a:pt x="174" y="204"/>
+                  <a:pt x="0" y="204"/>
+                  <a:pt x="0" y="88"/>
                 </a:cubicBezTo>
                 <a:close/>
               </a:path>
@@ -15192,34 +15235,34 @@
       </p:sp>
       <p:sp>
         <p:nvSpPr>
-          <p:cNvPr id="276" name=""/>
-          <p:cNvSpPr/>
-          <p:nvPr/>
-        </p:nvSpPr>
-        <p:spPr>
-          <a:xfrm>
-            <a:off x="1094400" y="5416200"/>
-            <a:ext cx="62640" cy="62640"/>
-          </a:xfrm>
-          <a:custGeom>
-            <a:avLst/>
-            <a:gdLst/>
-            <a:ahLst/>
-            <a:rect l="0" t="0" r="r" b="b"/>
-            <a:pathLst>
-              <a:path fill="none" w="174" h="174">
-                <a:moveTo>
-                  <a:pt x="174" y="86"/>
-                </a:moveTo>
-                <a:cubicBezTo>
-                  <a:pt x="174" y="203"/>
-                  <a:pt x="0" y="203"/>
-                  <a:pt x="0" y="86"/>
+          <p:cNvPr id="277" name=""/>
+          <p:cNvSpPr/>
+          <p:nvPr/>
+        </p:nvSpPr>
+        <p:spPr>
+          <a:xfrm>
+            <a:off x="1094400" y="5396760"/>
+            <a:ext cx="62640" cy="63000"/>
+          </a:xfrm>
+          <a:custGeom>
+            <a:avLst/>
+            <a:gdLst/>
+            <a:ahLst/>
+            <a:rect l="0" t="0" r="r" b="b"/>
+            <a:pathLst>
+              <a:path fill="none" w="174" h="175">
+                <a:moveTo>
+                  <a:pt x="174" y="88"/>
+                </a:moveTo>
+                <a:cubicBezTo>
+                  <a:pt x="174" y="204"/>
+                  <a:pt x="0" y="204"/>
+                  <a:pt x="0" y="88"/>
                 </a:cubicBezTo>
                 <a:cubicBezTo>
                   <a:pt x="0" y="-29"/>
                   <a:pt x="174" y="-29"/>
-                  <a:pt x="174" y="86"/>
+                  <a:pt x="174" y="88"/>
                 </a:cubicBezTo>
               </a:path>
             </a:pathLst>
@@ -15249,13 +15292,13 @@
       </p:sp>
       <p:sp>
         <p:nvSpPr>
-          <p:cNvPr id="277" name=""/>
-          <p:cNvSpPr/>
-          <p:nvPr/>
-        </p:nvSpPr>
-        <p:spPr>
-          <a:xfrm>
-            <a:off x="2051640" y="5187960"/>
+          <p:cNvPr id="278" name=""/>
+          <p:cNvSpPr/>
+          <p:nvPr/>
+        </p:nvSpPr>
+        <p:spPr>
+          <a:xfrm>
+            <a:off x="2051640" y="5171760"/>
             <a:ext cx="62640" cy="62640"/>
           </a:xfrm>
           <a:custGeom>
@@ -15307,13 +15350,13 @@
       </p:sp>
       <p:sp>
         <p:nvSpPr>
-          <p:cNvPr id="278" name=""/>
-          <p:cNvSpPr/>
-          <p:nvPr/>
-        </p:nvSpPr>
-        <p:spPr>
-          <a:xfrm>
-            <a:off x="2051640" y="5187960"/>
+          <p:cNvPr id="279" name=""/>
+          <p:cNvSpPr/>
+          <p:nvPr/>
+        </p:nvSpPr>
+        <p:spPr>
+          <a:xfrm>
+            <a:off x="2051640" y="5171760"/>
             <a:ext cx="62640" cy="62640"/>
           </a:xfrm>
           <a:custGeom>
@@ -15364,34 +15407,34 @@
       </p:sp>
       <p:sp>
         <p:nvSpPr>
-          <p:cNvPr id="279" name=""/>
-          <p:cNvSpPr/>
-          <p:nvPr/>
-        </p:nvSpPr>
-        <p:spPr>
-          <a:xfrm>
-            <a:off x="3008520" y="5212080"/>
-            <a:ext cx="63000" cy="62640"/>
-          </a:xfrm>
-          <a:custGeom>
-            <a:avLst/>
-            <a:gdLst/>
-            <a:ahLst/>
-            <a:rect l="0" t="0" r="r" b="b"/>
-            <a:pathLst>
-              <a:path w="175" h="174">
-                <a:moveTo>
-                  <a:pt x="0" y="86"/>
+          <p:cNvPr id="280" name=""/>
+          <p:cNvSpPr/>
+          <p:nvPr/>
+        </p:nvSpPr>
+        <p:spPr>
+          <a:xfrm>
+            <a:off x="3008520" y="5195520"/>
+            <a:ext cx="63000" cy="63000"/>
+          </a:xfrm>
+          <a:custGeom>
+            <a:avLst/>
+            <a:gdLst/>
+            <a:ahLst/>
+            <a:rect l="0" t="0" r="r" b="b"/>
+            <a:pathLst>
+              <a:path w="175" h="175">
+                <a:moveTo>
+                  <a:pt x="0" y="88"/>
                 </a:moveTo>
                 <a:cubicBezTo>
                   <a:pt x="0" y="-29"/>
                   <a:pt x="175" y="-29"/>
-                  <a:pt x="175" y="86"/>
-                </a:cubicBezTo>
-                <a:cubicBezTo>
-                  <a:pt x="175" y="203"/>
-                  <a:pt x="0" y="203"/>
-                  <a:pt x="0" y="86"/>
+                  <a:pt x="175" y="88"/>
+                </a:cubicBezTo>
+                <a:cubicBezTo>
+                  <a:pt x="175" y="204"/>
+                  <a:pt x="0" y="204"/>
+                  <a:pt x="0" y="88"/>
                 </a:cubicBezTo>
                 <a:close/>
               </a:path>
@@ -15422,34 +15465,34 @@
       </p:sp>
       <p:sp>
         <p:nvSpPr>
-          <p:cNvPr id="280" name=""/>
-          <p:cNvSpPr/>
-          <p:nvPr/>
-        </p:nvSpPr>
-        <p:spPr>
-          <a:xfrm>
-            <a:off x="3008520" y="5212080"/>
-            <a:ext cx="63000" cy="62640"/>
-          </a:xfrm>
-          <a:custGeom>
-            <a:avLst/>
-            <a:gdLst/>
-            <a:ahLst/>
-            <a:rect l="0" t="0" r="r" b="b"/>
-            <a:pathLst>
-              <a:path fill="none" w="175" h="174">
-                <a:moveTo>
-                  <a:pt x="175" y="86"/>
-                </a:moveTo>
-                <a:cubicBezTo>
-                  <a:pt x="175" y="203"/>
-                  <a:pt x="0" y="203"/>
-                  <a:pt x="0" y="86"/>
+          <p:cNvPr id="281" name=""/>
+          <p:cNvSpPr/>
+          <p:nvPr/>
+        </p:nvSpPr>
+        <p:spPr>
+          <a:xfrm>
+            <a:off x="3008520" y="5195520"/>
+            <a:ext cx="63000" cy="63000"/>
+          </a:xfrm>
+          <a:custGeom>
+            <a:avLst/>
+            <a:gdLst/>
+            <a:ahLst/>
+            <a:rect l="0" t="0" r="r" b="b"/>
+            <a:pathLst>
+              <a:path fill="none" w="175" h="175">
+                <a:moveTo>
+                  <a:pt x="175" y="88"/>
+                </a:moveTo>
+                <a:cubicBezTo>
+                  <a:pt x="175" y="204"/>
+                  <a:pt x="0" y="204"/>
+                  <a:pt x="0" y="88"/>
                 </a:cubicBezTo>
                 <a:cubicBezTo>
                   <a:pt x="0" y="-29"/>
                   <a:pt x="175" y="-29"/>
-                  <a:pt x="175" y="86"/>
+                  <a:pt x="175" y="88"/>
                 </a:cubicBezTo>
               </a:path>
             </a:pathLst>
@@ -15479,34 +15522,34 @@
       </p:sp>
       <p:sp>
         <p:nvSpPr>
-          <p:cNvPr id="281" name=""/>
-          <p:cNvSpPr/>
-          <p:nvPr/>
-        </p:nvSpPr>
-        <p:spPr>
-          <a:xfrm>
-            <a:off x="3965760" y="5212440"/>
-            <a:ext cx="62640" cy="62640"/>
-          </a:xfrm>
-          <a:custGeom>
-            <a:avLst/>
-            <a:gdLst/>
-            <a:ahLst/>
-            <a:rect l="0" t="0" r="r" b="b"/>
-            <a:pathLst>
-              <a:path w="174" h="174">
-                <a:moveTo>
-                  <a:pt x="0" y="86"/>
+          <p:cNvPr id="282" name=""/>
+          <p:cNvSpPr/>
+          <p:nvPr/>
+        </p:nvSpPr>
+        <p:spPr>
+          <a:xfrm>
+            <a:off x="3965760" y="5195880"/>
+            <a:ext cx="62640" cy="63000"/>
+          </a:xfrm>
+          <a:custGeom>
+            <a:avLst/>
+            <a:gdLst/>
+            <a:ahLst/>
+            <a:rect l="0" t="0" r="r" b="b"/>
+            <a:pathLst>
+              <a:path w="174" h="175">
+                <a:moveTo>
+                  <a:pt x="0" y="87"/>
                 </a:moveTo>
                 <a:cubicBezTo>
                   <a:pt x="0" y="-29"/>
                   <a:pt x="174" y="-29"/>
-                  <a:pt x="174" y="86"/>
-                </a:cubicBezTo>
-                <a:cubicBezTo>
-                  <a:pt x="174" y="203"/>
-                  <a:pt x="0" y="203"/>
-                  <a:pt x="0" y="86"/>
+                  <a:pt x="174" y="87"/>
+                </a:cubicBezTo>
+                <a:cubicBezTo>
+                  <a:pt x="174" y="204"/>
+                  <a:pt x="0" y="204"/>
+                  <a:pt x="0" y="87"/>
                 </a:cubicBezTo>
                 <a:close/>
               </a:path>
@@ -15537,34 +15580,34 @@
       </p:sp>
       <p:sp>
         <p:nvSpPr>
-          <p:cNvPr id="282" name=""/>
-          <p:cNvSpPr/>
-          <p:nvPr/>
-        </p:nvSpPr>
-        <p:spPr>
-          <a:xfrm>
-            <a:off x="3965760" y="5212440"/>
-            <a:ext cx="62640" cy="62640"/>
-          </a:xfrm>
-          <a:custGeom>
-            <a:avLst/>
-            <a:gdLst/>
-            <a:ahLst/>
-            <a:rect l="0" t="0" r="r" b="b"/>
-            <a:pathLst>
-              <a:path fill="none" w="174" h="174">
-                <a:moveTo>
-                  <a:pt x="174" y="86"/>
-                </a:moveTo>
-                <a:cubicBezTo>
-                  <a:pt x="174" y="203"/>
-                  <a:pt x="0" y="203"/>
-                  <a:pt x="0" y="86"/>
+          <p:cNvPr id="283" name=""/>
+          <p:cNvSpPr/>
+          <p:nvPr/>
+        </p:nvSpPr>
+        <p:spPr>
+          <a:xfrm>
+            <a:off x="3965760" y="5195880"/>
+            <a:ext cx="62640" cy="63000"/>
+          </a:xfrm>
+          <a:custGeom>
+            <a:avLst/>
+            <a:gdLst/>
+            <a:ahLst/>
+            <a:rect l="0" t="0" r="r" b="b"/>
+            <a:pathLst>
+              <a:path fill="none" w="174" h="175">
+                <a:moveTo>
+                  <a:pt x="174" y="87"/>
+                </a:moveTo>
+                <a:cubicBezTo>
+                  <a:pt x="174" y="204"/>
+                  <a:pt x="0" y="204"/>
+                  <a:pt x="0" y="87"/>
                 </a:cubicBezTo>
                 <a:cubicBezTo>
                   <a:pt x="0" y="-29"/>
                   <a:pt x="174" y="-29"/>
-                  <a:pt x="174" y="86"/>
+                  <a:pt x="174" y="87"/>
                 </a:cubicBezTo>
               </a:path>
             </a:pathLst>
@@ -15594,13 +15637,13 @@
       </p:sp>
       <p:sp>
         <p:nvSpPr>
-          <p:cNvPr id="283" name=""/>
-          <p:cNvSpPr/>
-          <p:nvPr/>
-        </p:nvSpPr>
-        <p:spPr>
-          <a:xfrm>
-            <a:off x="4923000" y="5206320"/>
+          <p:cNvPr id="284" name=""/>
+          <p:cNvSpPr/>
+          <p:nvPr/>
+        </p:nvSpPr>
+        <p:spPr>
+          <a:xfrm>
+            <a:off x="4923000" y="5190480"/>
             <a:ext cx="62640" cy="63000"/>
           </a:xfrm>
           <a:custGeom>
@@ -15652,13 +15695,13 @@
       </p:sp>
       <p:sp>
         <p:nvSpPr>
-          <p:cNvPr id="284" name=""/>
-          <p:cNvSpPr/>
-          <p:nvPr/>
-        </p:nvSpPr>
-        <p:spPr>
-          <a:xfrm>
-            <a:off x="4923000" y="5206320"/>
+          <p:cNvPr id="285" name=""/>
+          <p:cNvSpPr/>
+          <p:nvPr/>
+        </p:nvSpPr>
+        <p:spPr>
+          <a:xfrm>
+            <a:off x="4923000" y="5190480"/>
             <a:ext cx="62640" cy="63000"/>
           </a:xfrm>
           <a:custGeom>
@@ -15709,22 +15752,22 @@
       </p:sp>
       <p:sp>
         <p:nvSpPr>
-          <p:cNvPr id="285" name=""/>
-          <p:cNvSpPr/>
-          <p:nvPr/>
-        </p:nvSpPr>
-        <p:spPr>
-          <a:xfrm>
-            <a:off x="5879880" y="5142960"/>
-            <a:ext cx="62640" cy="63000"/>
-          </a:xfrm>
-          <a:custGeom>
-            <a:avLst/>
-            <a:gdLst/>
-            <a:ahLst/>
-            <a:rect l="0" t="0" r="r" b="b"/>
-            <a:pathLst>
-              <a:path w="174" h="175">
+          <p:cNvPr id="286" name=""/>
+          <p:cNvSpPr/>
+          <p:nvPr/>
+        </p:nvSpPr>
+        <p:spPr>
+          <a:xfrm>
+            <a:off x="5879880" y="5127480"/>
+            <a:ext cx="62640" cy="62280"/>
+          </a:xfrm>
+          <a:custGeom>
+            <a:avLst/>
+            <a:gdLst/>
+            <a:ahLst/>
+            <a:rect l="0" t="0" r="r" b="b"/>
+            <a:pathLst>
+              <a:path w="174" h="173">
                 <a:moveTo>
                   <a:pt x="0" y="87"/>
                 </a:moveTo>
@@ -15734,8 +15777,8 @@
                   <a:pt x="174" y="87"/>
                 </a:cubicBezTo>
                 <a:cubicBezTo>
-                  <a:pt x="174" y="204"/>
-                  <a:pt x="0" y="204"/>
+                  <a:pt x="174" y="202"/>
+                  <a:pt x="0" y="202"/>
                   <a:pt x="0" y="87"/>
                 </a:cubicBezTo>
                 <a:close/>
@@ -15767,28 +15810,28 @@
       </p:sp>
       <p:sp>
         <p:nvSpPr>
-          <p:cNvPr id="286" name=""/>
-          <p:cNvSpPr/>
-          <p:nvPr/>
-        </p:nvSpPr>
-        <p:spPr>
-          <a:xfrm>
-            <a:off x="5879880" y="5142960"/>
-            <a:ext cx="62640" cy="63000"/>
-          </a:xfrm>
-          <a:custGeom>
-            <a:avLst/>
-            <a:gdLst/>
-            <a:ahLst/>
-            <a:rect l="0" t="0" r="r" b="b"/>
-            <a:pathLst>
-              <a:path fill="none" w="174" h="175">
+          <p:cNvPr id="287" name=""/>
+          <p:cNvSpPr/>
+          <p:nvPr/>
+        </p:nvSpPr>
+        <p:spPr>
+          <a:xfrm>
+            <a:off x="5879880" y="5127480"/>
+            <a:ext cx="62640" cy="62280"/>
+          </a:xfrm>
+          <a:custGeom>
+            <a:avLst/>
+            <a:gdLst/>
+            <a:ahLst/>
+            <a:rect l="0" t="0" r="r" b="b"/>
+            <a:pathLst>
+              <a:path fill="none" w="174" h="173">
                 <a:moveTo>
                   <a:pt x="174" y="87"/>
                 </a:moveTo>
                 <a:cubicBezTo>
-                  <a:pt x="174" y="204"/>
-                  <a:pt x="0" y="204"/>
+                  <a:pt x="174" y="202"/>
+                  <a:pt x="0" y="202"/>
                   <a:pt x="0" y="87"/>
                 </a:cubicBezTo>
                 <a:cubicBezTo>
@@ -15824,13 +15867,13 @@
       </p:sp>
       <p:sp>
         <p:nvSpPr>
-          <p:cNvPr id="287" name=""/>
-          <p:cNvSpPr/>
-          <p:nvPr/>
-        </p:nvSpPr>
-        <p:spPr>
-          <a:xfrm>
-            <a:off x="1094400" y="5367600"/>
+          <p:cNvPr id="288" name=""/>
+          <p:cNvSpPr/>
+          <p:nvPr/>
+        </p:nvSpPr>
+        <p:spPr>
+          <a:xfrm>
+            <a:off x="1094400" y="5348880"/>
             <a:ext cx="62640" cy="62640"/>
           </a:xfrm>
           <a:custGeom>
@@ -15841,17 +15884,17 @@
             <a:pathLst>
               <a:path w="174" h="174">
                 <a:moveTo>
-                  <a:pt x="0" y="88"/>
+                  <a:pt x="0" y="87"/>
                 </a:moveTo>
                 <a:cubicBezTo>
                   <a:pt x="0" y="-29"/>
                   <a:pt x="174" y="-29"/>
-                  <a:pt x="174" y="88"/>
+                  <a:pt x="174" y="87"/>
                 </a:cubicBezTo>
                 <a:cubicBezTo>
                   <a:pt x="174" y="203"/>
                   <a:pt x="0" y="203"/>
-                  <a:pt x="0" y="88"/>
+                  <a:pt x="0" y="87"/>
                 </a:cubicBezTo>
                 <a:close/>
               </a:path>
@@ -15882,13 +15925,13 @@
       </p:sp>
       <p:sp>
         <p:nvSpPr>
-          <p:cNvPr id="288" name=""/>
-          <p:cNvSpPr/>
-          <p:nvPr/>
-        </p:nvSpPr>
-        <p:spPr>
-          <a:xfrm>
-            <a:off x="1094400" y="5367600"/>
+          <p:cNvPr id="289" name=""/>
+          <p:cNvSpPr/>
+          <p:nvPr/>
+        </p:nvSpPr>
+        <p:spPr>
+          <a:xfrm>
+            <a:off x="1094400" y="5348880"/>
             <a:ext cx="62640" cy="62640"/>
           </a:xfrm>
           <a:custGeom>
@@ -15899,17 +15942,17 @@
             <a:pathLst>
               <a:path fill="none" w="174" h="174">
                 <a:moveTo>
-                  <a:pt x="174" y="88"/>
+                  <a:pt x="174" y="87"/>
                 </a:moveTo>
                 <a:cubicBezTo>
                   <a:pt x="174" y="203"/>
                   <a:pt x="0" y="203"/>
-                  <a:pt x="0" y="88"/>
+                  <a:pt x="0" y="87"/>
                 </a:cubicBezTo>
                 <a:cubicBezTo>
                   <a:pt x="0" y="-29"/>
                   <a:pt x="174" y="-29"/>
-                  <a:pt x="174" y="88"/>
+                  <a:pt x="174" y="87"/>
                 </a:cubicBezTo>
               </a:path>
             </a:pathLst>
@@ -15939,34 +15982,34 @@
       </p:sp>
       <p:sp>
         <p:nvSpPr>
-          <p:cNvPr id="289" name=""/>
-          <p:cNvSpPr/>
-          <p:nvPr/>
-        </p:nvSpPr>
-        <p:spPr>
-          <a:xfrm>
-            <a:off x="2051640" y="5400000"/>
-            <a:ext cx="62640" cy="62640"/>
-          </a:xfrm>
-          <a:custGeom>
-            <a:avLst/>
-            <a:gdLst/>
-            <a:ahLst/>
-            <a:rect l="0" t="0" r="r" b="b"/>
-            <a:pathLst>
-              <a:path w="174" h="174">
-                <a:moveTo>
-                  <a:pt x="0" y="86"/>
+          <p:cNvPr id="290" name=""/>
+          <p:cNvSpPr/>
+          <p:nvPr/>
+        </p:nvSpPr>
+        <p:spPr>
+          <a:xfrm>
+            <a:off x="2051640" y="5394240"/>
+            <a:ext cx="62640" cy="63000"/>
+          </a:xfrm>
+          <a:custGeom>
+            <a:avLst/>
+            <a:gdLst/>
+            <a:ahLst/>
+            <a:rect l="0" t="0" r="r" b="b"/>
+            <a:pathLst>
+              <a:path w="174" h="175">
+                <a:moveTo>
+                  <a:pt x="0" y="88"/>
                 </a:moveTo>
                 <a:cubicBezTo>
                   <a:pt x="0" y="-29"/>
                   <a:pt x="174" y="-29"/>
-                  <a:pt x="174" y="86"/>
-                </a:cubicBezTo>
-                <a:cubicBezTo>
-                  <a:pt x="174" y="203"/>
-                  <a:pt x="0" y="203"/>
-                  <a:pt x="0" y="86"/>
+                  <a:pt x="174" y="88"/>
+                </a:cubicBezTo>
+                <a:cubicBezTo>
+                  <a:pt x="174" y="204"/>
+                  <a:pt x="0" y="204"/>
+                  <a:pt x="0" y="88"/>
                 </a:cubicBezTo>
                 <a:close/>
               </a:path>
@@ -15997,34 +16040,34 @@
       </p:sp>
       <p:sp>
         <p:nvSpPr>
-          <p:cNvPr id="290" name=""/>
-          <p:cNvSpPr/>
-          <p:nvPr/>
-        </p:nvSpPr>
-        <p:spPr>
-          <a:xfrm>
-            <a:off x="2051640" y="5400000"/>
-            <a:ext cx="62640" cy="62640"/>
-          </a:xfrm>
-          <a:custGeom>
-            <a:avLst/>
-            <a:gdLst/>
-            <a:ahLst/>
-            <a:rect l="0" t="0" r="r" b="b"/>
-            <a:pathLst>
-              <a:path fill="none" w="174" h="174">
-                <a:moveTo>
-                  <a:pt x="174" y="86"/>
-                </a:moveTo>
-                <a:cubicBezTo>
-                  <a:pt x="174" y="203"/>
-                  <a:pt x="0" y="203"/>
-                  <a:pt x="0" y="86"/>
+          <p:cNvPr id="291" name=""/>
+          <p:cNvSpPr/>
+          <p:nvPr/>
+        </p:nvSpPr>
+        <p:spPr>
+          <a:xfrm>
+            <a:off x="2051640" y="5394240"/>
+            <a:ext cx="62640" cy="63000"/>
+          </a:xfrm>
+          <a:custGeom>
+            <a:avLst/>
+            <a:gdLst/>
+            <a:ahLst/>
+            <a:rect l="0" t="0" r="r" b="b"/>
+            <a:pathLst>
+              <a:path fill="none" w="174" h="175">
+                <a:moveTo>
+                  <a:pt x="174" y="88"/>
+                </a:moveTo>
+                <a:cubicBezTo>
+                  <a:pt x="174" y="204"/>
+                  <a:pt x="0" y="204"/>
+                  <a:pt x="0" y="88"/>
                 </a:cubicBezTo>
                 <a:cubicBezTo>
                   <a:pt x="0" y="-29"/>
                   <a:pt x="174" y="-29"/>
-                  <a:pt x="174" y="86"/>
+                  <a:pt x="174" y="88"/>
                 </a:cubicBezTo>
               </a:path>
             </a:pathLst>
@@ -16054,13 +16097,13 @@
       </p:sp>
       <p:sp>
         <p:nvSpPr>
-          <p:cNvPr id="291" name=""/>
-          <p:cNvSpPr/>
-          <p:nvPr/>
-        </p:nvSpPr>
-        <p:spPr>
-          <a:xfrm>
-            <a:off x="3008520" y="5391360"/>
+          <p:cNvPr id="292" name=""/>
+          <p:cNvSpPr/>
+          <p:nvPr/>
+        </p:nvSpPr>
+        <p:spPr>
+          <a:xfrm>
+            <a:off x="3008520" y="5386320"/>
             <a:ext cx="63000" cy="63000"/>
           </a:xfrm>
           <a:custGeom>
@@ -16071,17 +16114,17 @@
             <a:pathLst>
               <a:path w="175" h="175">
                 <a:moveTo>
-                  <a:pt x="0" y="87"/>
+                  <a:pt x="0" y="88"/>
                 </a:moveTo>
                 <a:cubicBezTo>
                   <a:pt x="0" y="-29"/>
                   <a:pt x="175" y="-29"/>
-                  <a:pt x="175" y="87"/>
+                  <a:pt x="175" y="88"/>
                 </a:cubicBezTo>
                 <a:cubicBezTo>
                   <a:pt x="175" y="204"/>
                   <a:pt x="0" y="204"/>
-                  <a:pt x="0" y="87"/>
+                  <a:pt x="0" y="88"/>
                 </a:cubicBezTo>
                 <a:close/>
               </a:path>
@@ -16112,13 +16155,13 @@
       </p:sp>
       <p:sp>
         <p:nvSpPr>
-          <p:cNvPr id="292" name=""/>
-          <p:cNvSpPr/>
-          <p:nvPr/>
-        </p:nvSpPr>
-        <p:spPr>
-          <a:xfrm>
-            <a:off x="3008520" y="5391360"/>
+          <p:cNvPr id="293" name=""/>
+          <p:cNvSpPr/>
+          <p:nvPr/>
+        </p:nvSpPr>
+        <p:spPr>
+          <a:xfrm>
+            <a:off x="3008520" y="5386320"/>
             <a:ext cx="63000" cy="63000"/>
           </a:xfrm>
           <a:custGeom>
@@ -16129,17 +16172,17 @@
             <a:pathLst>
               <a:path fill="none" w="175" h="175">
                 <a:moveTo>
-                  <a:pt x="175" y="87"/>
+                  <a:pt x="175" y="88"/>
                 </a:moveTo>
                 <a:cubicBezTo>
                   <a:pt x="175" y="204"/>
                   <a:pt x="0" y="204"/>
-                  <a:pt x="0" y="87"/>
+                  <a:pt x="0" y="88"/>
                 </a:cubicBezTo>
                 <a:cubicBezTo>
                   <a:pt x="0" y="-29"/>
                   <a:pt x="175" y="-29"/>
-                  <a:pt x="175" y="87"/>
+                  <a:pt x="175" y="88"/>
                 </a:cubicBezTo>
               </a:path>
             </a:pathLst>
@@ -16169,13 +16212,13 @@
       </p:sp>
       <p:sp>
         <p:nvSpPr>
-          <p:cNvPr id="293" name=""/>
-          <p:cNvSpPr/>
-          <p:nvPr/>
-        </p:nvSpPr>
-        <p:spPr>
-          <a:xfrm>
-            <a:off x="3965760" y="5392440"/>
+          <p:cNvPr id="294" name=""/>
+          <p:cNvSpPr/>
+          <p:nvPr/>
+        </p:nvSpPr>
+        <p:spPr>
+          <a:xfrm>
+            <a:off x="3965760" y="5386680"/>
             <a:ext cx="62640" cy="63000"/>
           </a:xfrm>
           <a:custGeom>
@@ -16186,17 +16229,17 @@
             <a:pathLst>
               <a:path w="174" h="175">
                 <a:moveTo>
-                  <a:pt x="0" y="87"/>
+                  <a:pt x="0" y="88"/>
                 </a:moveTo>
                 <a:cubicBezTo>
                   <a:pt x="0" y="-29"/>
                   <a:pt x="174" y="-29"/>
-                  <a:pt x="174" y="87"/>
+                  <a:pt x="174" y="88"/>
                 </a:cubicBezTo>
                 <a:cubicBezTo>
                   <a:pt x="174" y="204"/>
                   <a:pt x="0" y="204"/>
-                  <a:pt x="0" y="87"/>
+                  <a:pt x="0" y="88"/>
                 </a:cubicBezTo>
                 <a:close/>
               </a:path>
@@ -16227,13 +16270,13 @@
       </p:sp>
       <p:sp>
         <p:nvSpPr>
-          <p:cNvPr id="294" name=""/>
-          <p:cNvSpPr/>
-          <p:nvPr/>
-        </p:nvSpPr>
-        <p:spPr>
-          <a:xfrm>
-            <a:off x="3965760" y="5392440"/>
+          <p:cNvPr id="295" name=""/>
+          <p:cNvSpPr/>
+          <p:nvPr/>
+        </p:nvSpPr>
+        <p:spPr>
+          <a:xfrm>
+            <a:off x="3965760" y="5386680"/>
             <a:ext cx="62640" cy="63000"/>
           </a:xfrm>
           <a:custGeom>
@@ -16244,17 +16287,17 @@
             <a:pathLst>
               <a:path fill="none" w="174" h="175">
                 <a:moveTo>
-                  <a:pt x="174" y="87"/>
+                  <a:pt x="174" y="88"/>
                 </a:moveTo>
                 <a:cubicBezTo>
                   <a:pt x="174" y="204"/>
                   <a:pt x="0" y="204"/>
-                  <a:pt x="0" y="87"/>
+                  <a:pt x="0" y="88"/>
                 </a:cubicBezTo>
                 <a:cubicBezTo>
                   <a:pt x="0" y="-29"/>
                   <a:pt x="174" y="-29"/>
-                  <a:pt x="174" y="87"/>
+                  <a:pt x="174" y="88"/>
                 </a:cubicBezTo>
               </a:path>
             </a:pathLst>
@@ -16284,13 +16327,13 @@
       </p:sp>
       <p:sp>
         <p:nvSpPr>
-          <p:cNvPr id="295" name=""/>
-          <p:cNvSpPr/>
-          <p:nvPr/>
-        </p:nvSpPr>
-        <p:spPr>
-          <a:xfrm>
-            <a:off x="4923000" y="5393160"/>
+          <p:cNvPr id="296" name=""/>
+          <p:cNvSpPr/>
+          <p:nvPr/>
+        </p:nvSpPr>
+        <p:spPr>
+          <a:xfrm>
+            <a:off x="4923000" y="5389200"/>
             <a:ext cx="62640" cy="63000"/>
           </a:xfrm>
           <a:custGeom>
@@ -16342,13 +16385,13 @@
       </p:sp>
       <p:sp>
         <p:nvSpPr>
-          <p:cNvPr id="296" name=""/>
-          <p:cNvSpPr/>
-          <p:nvPr/>
-        </p:nvSpPr>
-        <p:spPr>
-          <a:xfrm>
-            <a:off x="4923000" y="5393160"/>
+          <p:cNvPr id="297" name=""/>
+          <p:cNvSpPr/>
+          <p:nvPr/>
+        </p:nvSpPr>
+        <p:spPr>
+          <a:xfrm>
+            <a:off x="4923000" y="5389200"/>
             <a:ext cx="62640" cy="63000"/>
           </a:xfrm>
           <a:custGeom>
@@ -16399,7 +16442,7 @@
       </p:sp>
       <p:sp>
         <p:nvSpPr>
-          <p:cNvPr id="297" name=""/>
+          <p:cNvPr id="298" name=""/>
           <p:cNvSpPr/>
           <p:nvPr/>
         </p:nvSpPr>
@@ -16457,7 +16500,7 @@
       </p:sp>
       <p:sp>
         <p:nvSpPr>
-          <p:cNvPr id="298" name=""/>
+          <p:cNvPr id="299" name=""/>
           <p:cNvSpPr/>
           <p:nvPr/>
         </p:nvSpPr>
@@ -16514,7 +16557,7 @@
       </p:sp>
       <p:sp>
         <p:nvSpPr>
-          <p:cNvPr id="299" name=""/>
+          <p:cNvPr id="300" name=""/>
           <p:cNvSpPr/>
           <p:nvPr/>
         </p:nvSpPr>
@@ -16576,7 +16619,7 @@
       </p:sp>
       <p:sp>
         <p:nvSpPr>
-          <p:cNvPr id="300" name=""/>
+          <p:cNvPr id="301" name=""/>
           <p:cNvSpPr txBox="1"/>
           <p:nvPr/>
         </p:nvSpPr>
@@ -16624,7 +16667,7 @@
       </p:sp>
       <p:sp>
         <p:nvSpPr>
-          <p:cNvPr id="301" name=""/>
+          <p:cNvPr id="302" name=""/>
           <p:cNvSpPr/>
           <p:nvPr/>
         </p:nvSpPr>
@@ -16667,13 +16710,13 @@
       </p:sp>
       <p:sp>
         <p:nvSpPr>
-          <p:cNvPr id="302" name=""/>
+          <p:cNvPr id="303" name=""/>
           <p:cNvSpPr txBox="1"/>
           <p:nvPr/>
         </p:nvSpPr>
         <p:spPr>
           <a:xfrm>
-            <a:off x="1860480" y="3755520"/>
+            <a:off x="1860480" y="3754080"/>
             <a:ext cx="409680" cy="104040"/>
           </a:xfrm>
           <a:prstGeom prst="rect">
@@ -16715,13 +16758,61 @@
       </p:sp>
       <p:sp>
         <p:nvSpPr>
-          <p:cNvPr id="303" name=""/>
+          <p:cNvPr id="304" name=""/>
           <p:cNvSpPr txBox="1"/>
           <p:nvPr/>
         </p:nvSpPr>
         <p:spPr>
           <a:xfrm>
-            <a:off x="367560" y="5114160"/>
+            <a:off x="367560" y="5471280"/>
+            <a:ext cx="142560" cy="102600"/>
+          </a:xfrm>
+          <a:prstGeom prst="rect">
+            <a:avLst/>
+          </a:prstGeom>
+          <a:noFill/>
+          <a:ln w="0">
+            <a:noFill/>
+          </a:ln>
+        </p:spPr>
+        <p:txBody>
+          <a:bodyPr wrap="none" lIns="0" tIns="0" rIns="0" bIns="0" anchor="t">
+            <a:spAutoFit/>
+          </a:bodyPr>
+          <a:p>
+            <a:pPr/>
+            <a:r>
+              <a:rPr lang="en-US" sz="800" b="0" u="none" strike="noStrike">
+                <a:solidFill>
+                  <a:srgbClr val="262626"/>
+                </a:solidFill>
+                <a:effectLst/>
+                <a:uFillTx/>
+                <a:latin typeface="Arial"/>
+                <a:ea typeface="Arial"/>
+              </a:rPr>
+              <a:t>0.8</a:t>
+            </a:r>
+            <a:endParaRPr lang="en-US" sz="800" b="0" u="none" strike="noStrike">
+              <a:solidFill>
+                <a:srgbClr val="000000"/>
+              </a:solidFill>
+              <a:effectLst/>
+              <a:uFillTx/>
+              <a:latin typeface="Times New Roman"/>
+            </a:endParaRPr>
+          </a:p>
+        </p:txBody>
+      </p:sp>
+      <p:sp>
+        <p:nvSpPr>
+          <p:cNvPr id="305" name=""/>
+          <p:cNvSpPr txBox="1"/>
+          <p:nvPr/>
+        </p:nvSpPr>
+        <p:spPr>
+          <a:xfrm>
+            <a:off x="367560" y="5097960"/>
             <a:ext cx="142560" cy="102600"/>
           </a:xfrm>
           <a:prstGeom prst="rect">
@@ -16763,13 +16854,13 @@
       </p:sp>
       <p:sp>
         <p:nvSpPr>
-          <p:cNvPr id="304" name=""/>
+          <p:cNvPr id="306" name=""/>
           <p:cNvSpPr txBox="1"/>
           <p:nvPr/>
         </p:nvSpPr>
         <p:spPr>
           <a:xfrm>
-            <a:off x="367560" y="4736880"/>
+            <a:off x="367560" y="4724640"/>
             <a:ext cx="142560" cy="102600"/>
           </a:xfrm>
           <a:prstGeom prst="rect">
@@ -16811,13 +16902,13 @@
       </p:sp>
       <p:sp>
         <p:nvSpPr>
-          <p:cNvPr id="305" name=""/>
+          <p:cNvPr id="307" name=""/>
           <p:cNvSpPr txBox="1"/>
           <p:nvPr/>
         </p:nvSpPr>
         <p:spPr>
           <a:xfrm>
-            <a:off x="367560" y="4359240"/>
+            <a:off x="367560" y="4351320"/>
             <a:ext cx="142560" cy="102600"/>
           </a:xfrm>
           <a:prstGeom prst="rect">
@@ -16859,13 +16950,13 @@
       </p:sp>
       <p:sp>
         <p:nvSpPr>
-          <p:cNvPr id="306" name=""/>
+          <p:cNvPr id="308" name=""/>
           <p:cNvSpPr txBox="1"/>
           <p:nvPr/>
         </p:nvSpPr>
         <p:spPr>
           <a:xfrm>
-            <a:off x="367560" y="3981960"/>
+            <a:off x="367560" y="3978000"/>
             <a:ext cx="142560" cy="102600"/>
           </a:xfrm>
           <a:prstGeom prst="rect">
@@ -16907,13 +16998,13 @@
       </p:sp>
       <p:sp>
         <p:nvSpPr>
-          <p:cNvPr id="307" name=""/>
-          <p:cNvSpPr/>
-          <p:nvPr/>
-        </p:nvSpPr>
-        <p:spPr>
-          <a:xfrm>
-            <a:off x="519840" y="5164920"/>
+          <p:cNvPr id="309" name=""/>
+          <p:cNvSpPr/>
+          <p:nvPr/>
+        </p:nvSpPr>
+        <p:spPr>
+          <a:xfrm>
+            <a:off x="519840" y="5522040"/>
             <a:ext cx="31320" cy="0"/>
           </a:xfrm>
           <a:prstGeom prst="line">
@@ -16950,13 +17041,13 @@
       </p:sp>
       <p:sp>
         <p:nvSpPr>
-          <p:cNvPr id="308" name=""/>
-          <p:cNvSpPr/>
-          <p:nvPr/>
-        </p:nvSpPr>
-        <p:spPr>
-          <a:xfrm>
-            <a:off x="519840" y="4787280"/>
+          <p:cNvPr id="310" name=""/>
+          <p:cNvSpPr/>
+          <p:nvPr/>
+        </p:nvSpPr>
+        <p:spPr>
+          <a:xfrm>
+            <a:off x="519840" y="5148720"/>
             <a:ext cx="31320" cy="0"/>
           </a:xfrm>
           <a:prstGeom prst="line">
@@ -16993,13 +17084,13 @@
       </p:sp>
       <p:sp>
         <p:nvSpPr>
-          <p:cNvPr id="309" name=""/>
-          <p:cNvSpPr/>
-          <p:nvPr/>
-        </p:nvSpPr>
-        <p:spPr>
-          <a:xfrm>
-            <a:off x="519840" y="4410000"/>
+          <p:cNvPr id="311" name=""/>
+          <p:cNvSpPr/>
+          <p:nvPr/>
+        </p:nvSpPr>
+        <p:spPr>
+          <a:xfrm>
+            <a:off x="519840" y="4775400"/>
             <a:ext cx="31320" cy="0"/>
           </a:xfrm>
           <a:prstGeom prst="line">
@@ -17036,13 +17127,13 @@
       </p:sp>
       <p:sp>
         <p:nvSpPr>
-          <p:cNvPr id="310" name=""/>
-          <p:cNvSpPr/>
-          <p:nvPr/>
-        </p:nvSpPr>
-        <p:spPr>
-          <a:xfrm>
-            <a:off x="519840" y="4032720"/>
+          <p:cNvPr id="312" name=""/>
+          <p:cNvSpPr/>
+          <p:nvPr/>
+        </p:nvSpPr>
+        <p:spPr>
+          <a:xfrm>
+            <a:off x="519840" y="4402080"/>
             <a:ext cx="31320" cy="0"/>
           </a:xfrm>
           <a:prstGeom prst="line">
@@ -17079,13 +17170,13 @@
       </p:sp>
       <p:sp>
         <p:nvSpPr>
-          <p:cNvPr id="311" name=""/>
-          <p:cNvSpPr/>
-          <p:nvPr/>
-        </p:nvSpPr>
-        <p:spPr>
-          <a:xfrm>
-            <a:off x="519840" y="3655080"/>
+          <p:cNvPr id="313" name=""/>
+          <p:cNvSpPr/>
+          <p:nvPr/>
+        </p:nvSpPr>
+        <p:spPr>
+          <a:xfrm>
+            <a:off x="519840" y="4028760"/>
             <a:ext cx="31320" cy="0"/>
           </a:xfrm>
           <a:prstGeom prst="line">
@@ -17122,7 +17213,50 @@
       </p:sp>
       <p:sp>
         <p:nvSpPr>
-          <p:cNvPr id="312" name=""/>
+          <p:cNvPr id="314" name=""/>
+          <p:cNvSpPr/>
+          <p:nvPr/>
+        </p:nvSpPr>
+        <p:spPr>
+          <a:xfrm>
+            <a:off x="519840" y="3655440"/>
+            <a:ext cx="31320" cy="0"/>
+          </a:xfrm>
+          <a:prstGeom prst="line">
+            <a:avLst/>
+          </a:prstGeom>
+          <a:ln w="7920">
+            <a:solidFill>
+              <a:srgbClr val="333333"/>
+            </a:solidFill>
+            <a:round/>
+          </a:ln>
+        </p:spPr>
+        <p:style>
+          <a:lnRef idx="0"/>
+          <a:fillRef idx="0"/>
+          <a:effectRef idx="0"/>
+          <a:fontRef idx="minor"/>
+        </p:style>
+        <p:txBody>
+          <a:bodyPr lIns="3960" tIns="-3960" rIns="3960" bIns="-3960" anchor="t">
+            <a:noAutofit/>
+          </a:bodyPr>
+          <a:p>
+            <a:endParaRPr lang="en-US" sz="2400" b="0" u="none" strike="noStrike">
+              <a:solidFill>
+                <a:srgbClr val="000000"/>
+              </a:solidFill>
+              <a:effectLst/>
+              <a:uFillTx/>
+              <a:latin typeface="Times New Roman"/>
+            </a:endParaRPr>
+          </a:p>
+        </p:txBody>
+      </p:sp>
+      <p:sp>
+        <p:nvSpPr>
+          <p:cNvPr id="315" name=""/>
           <p:cNvSpPr/>
           <p:nvPr/>
         </p:nvSpPr>
@@ -17165,7 +17299,7 @@
       </p:sp>
       <p:sp>
         <p:nvSpPr>
-          <p:cNvPr id="313" name=""/>
+          <p:cNvPr id="316" name=""/>
           <p:cNvSpPr/>
           <p:nvPr/>
         </p:nvSpPr>
@@ -17208,7 +17342,7 @@
       </p:sp>
       <p:sp>
         <p:nvSpPr>
-          <p:cNvPr id="314" name=""/>
+          <p:cNvPr id="317" name=""/>
           <p:cNvSpPr/>
           <p:nvPr/>
         </p:nvSpPr>
@@ -17251,7 +17385,7 @@
       </p:sp>
       <p:sp>
         <p:nvSpPr>
-          <p:cNvPr id="315" name=""/>
+          <p:cNvPr id="318" name=""/>
           <p:cNvSpPr/>
           <p:nvPr/>
         </p:nvSpPr>
@@ -17294,7 +17428,7 @@
       </p:sp>
       <p:sp>
         <p:nvSpPr>
-          <p:cNvPr id="316" name=""/>
+          <p:cNvPr id="319" name=""/>
           <p:cNvSpPr/>
           <p:nvPr/>
         </p:nvSpPr>
@@ -17337,7 +17471,7 @@
       </p:sp>
       <p:sp>
         <p:nvSpPr>
-          <p:cNvPr id="317" name=""/>
+          <p:cNvPr id="320" name=""/>
           <p:cNvSpPr/>
           <p:nvPr/>
         </p:nvSpPr>
@@ -17380,7 +17514,7 @@
       </p:sp>
       <p:sp>
         <p:nvSpPr>
-          <p:cNvPr id="318" name=""/>
+          <p:cNvPr id="321" name=""/>
           <p:cNvSpPr/>
           <p:nvPr/>
         </p:nvSpPr>
@@ -17423,7 +17557,7 @@
       </p:sp>
       <p:sp>
         <p:nvSpPr>
-          <p:cNvPr id="319" name=""/>
+          <p:cNvPr id="322" name=""/>
           <p:cNvSpPr txBox="1"/>
           <p:nvPr/>
         </p:nvSpPr>
@@ -17471,7 +17605,7 @@
       </p:sp>
       <p:sp>
         <p:nvSpPr>
-          <p:cNvPr id="320" name=""/>
+          <p:cNvPr id="323" name=""/>
           <p:cNvSpPr txBox="1"/>
           <p:nvPr/>
         </p:nvSpPr>
@@ -17519,7 +17653,7 @@
       </p:sp>
       <p:sp>
         <p:nvSpPr>
-          <p:cNvPr id="321" name=""/>
+          <p:cNvPr id="324" name=""/>
           <p:cNvSpPr txBox="1"/>
           <p:nvPr/>
         </p:nvSpPr>
@@ -17567,7 +17701,7 @@
       </p:sp>
       <p:sp>
         <p:nvSpPr>
-          <p:cNvPr id="322" name=""/>
+          <p:cNvPr id="325" name=""/>
           <p:cNvSpPr txBox="1"/>
           <p:nvPr/>
         </p:nvSpPr>
@@ -17615,7 +17749,7 @@
       </p:sp>
       <p:sp>
         <p:nvSpPr>
-          <p:cNvPr id="323" name=""/>
+          <p:cNvPr id="326" name=""/>
           <p:cNvSpPr txBox="1"/>
           <p:nvPr/>
         </p:nvSpPr>
@@ -17663,7 +17797,7 @@
       </p:sp>
       <p:sp>
         <p:nvSpPr>
-          <p:cNvPr id="324" name=""/>
+          <p:cNvPr id="327" name=""/>
           <p:cNvSpPr txBox="1"/>
           <p:nvPr/>
         </p:nvSpPr>
@@ -17711,7 +17845,7 @@
       </p:sp>
       <p:sp>
         <p:nvSpPr>
-          <p:cNvPr id="325" name=""/>
+          <p:cNvPr id="328" name=""/>
           <p:cNvSpPr txBox="1"/>
           <p:nvPr/>
         </p:nvSpPr>
@@ -17759,7 +17893,7 @@
       </p:sp>
       <p:sp>
         <p:nvSpPr>
-          <p:cNvPr id="326" name=""/>
+          <p:cNvPr id="329" name=""/>
           <p:cNvSpPr/>
           <p:nvPr/>
         </p:nvSpPr>
@@ -17819,7 +17953,7 @@
       </p:sp>
       <p:sp>
         <p:nvSpPr>
-          <p:cNvPr id="327" name=""/>
+          <p:cNvPr id="330" name=""/>
           <p:cNvSpPr/>
           <p:nvPr/>
         </p:nvSpPr>
@@ -17879,7 +18013,7 @@
       </p:sp>
       <p:sp>
         <p:nvSpPr>
-          <p:cNvPr id="328" name=""/>
+          <p:cNvPr id="331" name=""/>
           <p:cNvSpPr/>
           <p:nvPr/>
         </p:nvSpPr>
@@ -17922,7 +18056,7 @@
       </p:sp>
       <p:sp>
         <p:nvSpPr>
-          <p:cNvPr id="329" name=""/>
+          <p:cNvPr id="332" name=""/>
           <p:cNvSpPr/>
           <p:nvPr/>
         </p:nvSpPr>
@@ -17980,7 +18114,7 @@
       </p:sp>
       <p:sp>
         <p:nvSpPr>
-          <p:cNvPr id="330" name=""/>
+          <p:cNvPr id="333" name=""/>
           <p:cNvSpPr/>
           <p:nvPr/>
         </p:nvSpPr>
@@ -18037,7 +18171,7 @@
       </p:sp>
       <p:sp>
         <p:nvSpPr>
-          <p:cNvPr id="331" name=""/>
+          <p:cNvPr id="334" name=""/>
           <p:cNvSpPr/>
           <p:nvPr/>
         </p:nvSpPr>
@@ -18097,7 +18231,7 @@
       </p:sp>
       <p:sp>
         <p:nvSpPr>
-          <p:cNvPr id="332" name=""/>
+          <p:cNvPr id="335" name=""/>
           <p:cNvSpPr/>
           <p:nvPr/>
         </p:nvSpPr>
@@ -18140,7 +18274,7 @@
       </p:sp>
       <p:sp>
         <p:nvSpPr>
-          <p:cNvPr id="333" name=""/>
+          <p:cNvPr id="336" name=""/>
           <p:cNvSpPr/>
           <p:nvPr/>
         </p:nvSpPr>
@@ -18198,7 +18332,7 @@
       </p:sp>
       <p:sp>
         <p:nvSpPr>
-          <p:cNvPr id="334" name=""/>
+          <p:cNvPr id="337" name=""/>
           <p:cNvSpPr/>
           <p:nvPr/>
         </p:nvSpPr>
@@ -18255,7 +18389,7 @@
       </p:sp>
       <p:sp>
         <p:nvSpPr>
-          <p:cNvPr id="335" name=""/>
+          <p:cNvPr id="338" name=""/>
           <p:cNvSpPr/>
           <p:nvPr/>
         </p:nvSpPr>
@@ -18315,7 +18449,7 @@
       </p:sp>
       <p:sp>
         <p:nvSpPr>
-          <p:cNvPr id="336" name=""/>
+          <p:cNvPr id="339" name=""/>
           <p:cNvSpPr/>
           <p:nvPr/>
         </p:nvSpPr>
@@ -18358,7 +18492,7 @@
       </p:sp>
       <p:sp>
         <p:nvSpPr>
-          <p:cNvPr id="337" name=""/>
+          <p:cNvPr id="340" name=""/>
           <p:cNvSpPr/>
           <p:nvPr/>
         </p:nvSpPr>
@@ -18416,7 +18550,7 @@
       </p:sp>
       <p:sp>
         <p:nvSpPr>
-          <p:cNvPr id="338" name=""/>
+          <p:cNvPr id="341" name=""/>
           <p:cNvSpPr/>
           <p:nvPr/>
         </p:nvSpPr>
@@ -18473,7 +18607,7 @@
       </p:sp>
       <p:sp>
         <p:nvSpPr>
-          <p:cNvPr id="339" name=""/>
+          <p:cNvPr id="342" name=""/>
           <p:cNvSpPr/>
           <p:nvPr/>
         </p:nvSpPr>
@@ -18533,7 +18667,7 @@
       </p:sp>
       <p:sp>
         <p:nvSpPr>
-          <p:cNvPr id="340" name=""/>
+          <p:cNvPr id="343" name=""/>
           <p:cNvSpPr/>
           <p:nvPr/>
         </p:nvSpPr>
@@ -18576,7 +18710,7 @@
       </p:sp>
       <p:sp>
         <p:nvSpPr>
-          <p:cNvPr id="341" name=""/>
+          <p:cNvPr id="344" name=""/>
           <p:cNvSpPr/>
           <p:nvPr/>
         </p:nvSpPr>
@@ -18634,7 +18768,7 @@
       </p:sp>
       <p:sp>
         <p:nvSpPr>
-          <p:cNvPr id="342" name=""/>
+          <p:cNvPr id="345" name=""/>
           <p:cNvSpPr/>
           <p:nvPr/>
         </p:nvSpPr>
@@ -18691,7 +18825,7 @@
       </p:sp>
       <p:sp>
         <p:nvSpPr>
-          <p:cNvPr id="343" name=""/>
+          <p:cNvPr id="346" name=""/>
           <p:cNvSpPr txBox="1"/>
           <p:nvPr/>
         </p:nvSpPr>
@@ -18739,7 +18873,7 @@
       </p:sp>
       <p:sp>
         <p:nvSpPr>
-          <p:cNvPr id="344" name=""/>
+          <p:cNvPr id="347" name=""/>
           <p:cNvSpPr txBox="1"/>
           <p:nvPr/>
         </p:nvSpPr>
@@ -18787,7 +18921,7 @@
       </p:sp>
       <p:sp>
         <p:nvSpPr>
-          <p:cNvPr id="345" name=""/>
+          <p:cNvPr id="348" name=""/>
           <p:cNvSpPr txBox="1"/>
           <p:nvPr/>
         </p:nvSpPr>
@@ -18835,7 +18969,7 @@
       </p:sp>
       <p:sp>
         <p:nvSpPr>
-          <p:cNvPr id="346" name=""/>
+          <p:cNvPr id="349" name=""/>
           <p:cNvSpPr txBox="1"/>
           <p:nvPr/>
         </p:nvSpPr>
@@ -18883,7 +19017,7 @@
       </p:sp>
       <p:sp>
         <p:nvSpPr>
-          <p:cNvPr id="347" name=""/>
+          <p:cNvPr id="350" name=""/>
           <p:cNvSpPr txBox="1"/>
           <p:nvPr/>
         </p:nvSpPr>
@@ -18931,7 +19065,7 @@
       </p:sp>
       <p:sp>
         <p:nvSpPr>
-          <p:cNvPr id="348" name=""/>
+          <p:cNvPr id="351" name=""/>
           <p:cNvSpPr txBox="1"/>
           <p:nvPr/>
         </p:nvSpPr>
@@ -18979,7 +19113,7 @@
       </p:sp>
       <p:sp>
         <p:nvSpPr>
-          <p:cNvPr id="349" name=""/>
+          <p:cNvPr id="352" name=""/>
           <p:cNvSpPr txBox="1"/>
           <p:nvPr/>
         </p:nvSpPr>
@@ -19027,7 +19161,7 @@
       </p:sp>
       <p:sp>
         <p:nvSpPr>
-          <p:cNvPr id="350" name=""/>
+          <p:cNvPr id="353" name=""/>
           <p:cNvSpPr txBox="1"/>
           <p:nvPr/>
         </p:nvSpPr>

</xml_diff>